<commit_message>
ajuste no slide base
</commit_message>
<xml_diff>
--- a/docs/interchange_presentation.pptx
+++ b/docs/interchange_presentation.pptx
@@ -5,16 +5,16 @@
     <p:sldMasterId id="2147483648" r:id="rId1"/>
   </p:sldMasterIdLst>
   <p:sldIdLst>
-    <p:sldId id="256" r:id="rId7"/>
-    <p:sldId id="257" r:id="rId8"/>
-    <p:sldId id="258" r:id="rId9"/>
-    <p:sldId id="259" r:id="rId10"/>
-    <p:sldId id="260" r:id="rId11"/>
-    <p:sldId id="261" r:id="rId12"/>
-    <p:sldId id="262" r:id="rId13"/>
-    <p:sldId id="263" r:id="rId14"/>
-    <p:sldId id="264" r:id="rId15"/>
-    <p:sldId id="265" r:id="rId16"/>
+    <p:sldId id="256" r:id="rId2"/>
+    <p:sldId id="257" r:id="rId3"/>
+    <p:sldId id="258" r:id="rId4"/>
+    <p:sldId id="259" r:id="rId5"/>
+    <p:sldId id="260" r:id="rId6"/>
+    <p:sldId id="261" r:id="rId7"/>
+    <p:sldId id="262" r:id="rId8"/>
+    <p:sldId id="263" r:id="rId9"/>
+    <p:sldId id="264" r:id="rId10"/>
+    <p:sldId id="265" r:id="rId11"/>
   </p:sldIdLst>
   <p:sldSz cx="9144000" cy="6858000" type="screen4x3"/>
   <p:notesSz cx="6858000" cy="9144000"/>
@@ -113,22 +113,42 @@
       </a:defRPr>
     </a:lvl9pPr>
   </p:defaultTextStyle>
+  <p:extLst>
+    <p:ext uri="{EFAFB233-063F-42B5-8137-9DF3F51BA10A}">
+      <p15:sldGuideLst xmlns:p15="http://schemas.microsoft.com/office/powerpoint/2012/main">
+        <p15:guide id="1" orient="horz" pos="2160">
+          <p15:clr>
+            <a:srgbClr val="A4A3A4"/>
+          </p15:clr>
+        </p15:guide>
+        <p15:guide id="2" pos="2880">
+          <p15:clr>
+            <a:srgbClr val="A4A3A4"/>
+          </p15:clr>
+        </p15:guide>
+      </p15:sldGuideLst>
+    </p:ext>
+  </p:extLst>
 </p:presentation>
 </file>
 
 <file path=ppt/charts/chart1.xml><?xml version="1.0" encoding="utf-8"?>
-<c:chartSpace xmlns:c="http://schemas.openxmlformats.org/drawingml/2006/chart" xmlns:a="http://schemas.openxmlformats.org/drawingml/2006/main" xmlns:r="http://schemas.openxmlformats.org/officeDocument/2006/relationships">
+<c:chartSpace xmlns:c="http://schemas.openxmlformats.org/drawingml/2006/chart" xmlns:a="http://schemas.openxmlformats.org/drawingml/2006/main" xmlns:r="http://schemas.openxmlformats.org/officeDocument/2006/relationships" xmlns:c16r2="http://schemas.microsoft.com/office/drawing/2015/06/chart">
   <c:date1904 val="0"/>
+  <c:lang val="pt-BR"/>
+  <c:roundedCorners val="1"/>
+  <c:style val="2"/>
   <c:chart>
     <c:title>
-      <c:layout/>
       <c:overlay val="0"/>
     </c:title>
     <c:autoTitleDeleted val="0"/>
     <c:plotArea>
+      <c:layout/>
       <c:barChart>
         <c:barDir val="col"/>
         <c:grouping val="clustered"/>
+        <c:varyColors val="1"/>
         <c:ser>
           <c:idx val="0"/>
           <c:order val="0"/>
@@ -143,6 +163,7 @@
               </c:strCache>
             </c:strRef>
           </c:tx>
+          <c:invertIfNegative val="1"/>
           <c:cat>
             <c:strRef>
               <c:f>Sheet1!$A$2:$A$6</c:f>
@@ -190,6 +211,11 @@
               </c:numCache>
             </c:numRef>
           </c:val>
+          <c:extLst>
+            <c:ext xmlns:c16="http://schemas.microsoft.com/office/drawing/2014/chart" uri="{C3380CC4-5D6E-409C-BE32-E72D297353CC}">
+              <c16:uniqueId val="{00000000-3B93-48B6-AB16-C048715773A4}"/>
+            </c:ext>
+          </c:extLst>
         </c:ser>
         <c:ser>
           <c:idx val="1"/>
@@ -205,6 +231,7 @@
               </c:strCache>
             </c:strRef>
           </c:tx>
+          <c:invertIfNegative val="1"/>
           <c:cat>
             <c:strRef>
               <c:f>Sheet1!$A$2:$A$6</c:f>
@@ -235,7 +262,7 @@
                 <c:formatCode>General</c:formatCode>
                 <c:ptCount val="5"/>
                 <c:pt idx="0">
-                  <c:v>1.1</c:v>
+                  <c:v>1.1000000000000001</c:v>
                 </c:pt>
                 <c:pt idx="1">
                   <c:v>1.2</c:v>
@@ -247,12 +274,26 @@
                   <c:v>1.8</c:v>
                 </c:pt>
                 <c:pt idx="4">
-                  <c:v>2.22</c:v>
+                  <c:v>2.2200000000000002</c:v>
                 </c:pt>
               </c:numCache>
             </c:numRef>
           </c:val>
+          <c:extLst>
+            <c:ext xmlns:c16="http://schemas.microsoft.com/office/drawing/2014/chart" uri="{C3380CC4-5D6E-409C-BE32-E72D297353CC}">
+              <c16:uniqueId val="{00000001-3B93-48B6-AB16-C048715773A4}"/>
+            </c:ext>
+          </c:extLst>
         </c:ser>
+        <c:dLbls>
+          <c:showLegendKey val="0"/>
+          <c:showVal val="0"/>
+          <c:showCatName val="0"/>
+          <c:showSerName val="0"/>
+          <c:showPercent val="0"/>
+          <c:showBubbleSize val="0"/>
+        </c:dLbls>
+        <c:gapWidth val="150"/>
         <c:axId val="-2068027336"/>
         <c:axId val="-2113994440"/>
       </c:barChart>
@@ -263,6 +304,7 @@
         </c:scaling>
         <c:delete val="0"/>
         <c:axPos val="b"/>
+        <c:numFmt formatCode="General" sourceLinked="0"/>
         <c:majorTickMark val="out"/>
         <c:minorTickMark val="none"/>
         <c:tickLblPos val="nextTo"/>
@@ -273,6 +315,7 @@
             <a:pPr>
               <a:defRPr sz="1000"/>
             </a:pPr>
+            <a:endParaRPr lang="pt-BR"/>
           </a:p>
         </c:txPr>
         <c:crossAx val="-2113994440"/>
@@ -285,8 +328,9 @@
       <c:valAx>
         <c:axId val="-2113994440"/>
         <c:scaling>
-          <c:max val="3.0"/>
-          <c:min val="0.0"/>
+          <c:orientation val="minMax"/>
+          <c:max val="3"/>
+          <c:min val="0"/>
         </c:scaling>
         <c:delete val="0"/>
         <c:axPos val="l"/>
@@ -299,6 +343,7 @@
             </a:ln>
           </c:spPr>
         </c:majorGridlines>
+        <c:numFmt formatCode="General" sourceLinked="1"/>
         <c:majorTickMark val="out"/>
         <c:minorTickMark val="none"/>
         <c:tickLblPos val="nextTo"/>
@@ -309,17 +354,22 @@
             <a:pPr>
               <a:defRPr sz="900"/>
             </a:pPr>
+            <a:endParaRPr lang="pt-BR"/>
           </a:p>
         </c:txPr>
         <c:crossAx val="-2068027336"/>
         <c:crosses val="autoZero"/>
+        <c:crossBetween val="between"/>
         <c:majorUnit val="0.5"/>
       </c:valAx>
     </c:plotArea>
     <c:legend>
       <c:legendPos val="tr"/>
+      <c:overlay val="1"/>
     </c:legend>
+    <c:plotVisOnly val="1"/>
     <c:dispBlanksAs val="gap"/>
+    <c:showDLblsOverMax val="1"/>
   </c:chart>
   <c:txPr>
     <a:bodyPr/>
@@ -328,7 +378,7 @@
       <a:pPr>
         <a:defRPr sz="1800"/>
       </a:pPr>
-      <a:endParaRPr lang="en-US"/>
+      <a:endParaRPr lang="pt-BR"/>
     </a:p>
   </c:txPr>
   <c:externalData r:id="rId1">
@@ -375,10 +425,9 @@
           <a:lstStyle/>
           <a:p>
             <a:r>
-              <a:rPr lang="en-US" smtClean="0"/>
+              <a:rPr lang="en-US"/>
               <a:t>Click to edit Master title style</a:t>
             </a:r>
-            <a:endParaRPr lang="en-US"/>
           </a:p>
         </p:txBody>
       </p:sp>
@@ -494,10 +543,9 @@
           </a:lstStyle>
           <a:p>
             <a:r>
-              <a:rPr lang="en-US" smtClean="0"/>
+              <a:rPr lang="en-US"/>
               <a:t>Click to edit Master subtitle style</a:t>
             </a:r>
-            <a:endParaRPr lang="en-US"/>
           </a:p>
         </p:txBody>
       </p:sp>
@@ -518,7 +566,7 @@
           <a:p>
             <a:fld id="{5BCAD085-E8A6-8845-BD4E-CB4CCA059FC4}" type="datetimeFigureOut">
               <a:rPr lang="en-US" smtClean="0"/>
-              <a:t>1/27/13</a:t>
+              <a:t>3/25/2026</a:t>
             </a:fld>
             <a:endParaRPr lang="en-US"/>
           </a:p>
@@ -560,7 +608,7 @@
           <a:p>
             <a:fld id="{C1FF6DA9-008F-8B48-92A6-B652298478BF}" type="slidenum">
               <a:rPr lang="en-US" smtClean="0"/>
-              <a:t>‹#›</a:t>
+              <a:t>‹nº›</a:t>
             </a:fld>
             <a:endParaRPr lang="en-US"/>
           </a:p>
@@ -612,10 +660,9 @@
           <a:lstStyle/>
           <a:p>
             <a:r>
-              <a:rPr lang="en-US" smtClean="0"/>
+              <a:rPr lang="en-US"/>
               <a:t>Click to edit Master title style</a:t>
             </a:r>
-            <a:endParaRPr lang="en-US"/>
           </a:p>
         </p:txBody>
       </p:sp>
@@ -636,38 +683,37 @@
           <a:p>
             <a:pPr lvl="0"/>
             <a:r>
-              <a:rPr lang="en-US" smtClean="0"/>
+              <a:rPr lang="en-US"/>
               <a:t>Click to edit Master text styles</a:t>
             </a:r>
           </a:p>
           <a:p>
             <a:pPr lvl="1"/>
             <a:r>
-              <a:rPr lang="en-US" smtClean="0"/>
+              <a:rPr lang="en-US"/>
               <a:t>Second level</a:t>
             </a:r>
           </a:p>
           <a:p>
             <a:pPr lvl="2"/>
             <a:r>
-              <a:rPr lang="en-US" smtClean="0"/>
+              <a:rPr lang="en-US"/>
               <a:t>Third level</a:t>
             </a:r>
           </a:p>
           <a:p>
             <a:pPr lvl="3"/>
             <a:r>
-              <a:rPr lang="en-US" smtClean="0"/>
+              <a:rPr lang="en-US"/>
               <a:t>Fourth level</a:t>
             </a:r>
           </a:p>
           <a:p>
             <a:pPr lvl="4"/>
             <a:r>
-              <a:rPr lang="en-US" smtClean="0"/>
+              <a:rPr lang="en-US"/>
               <a:t>Fifth level</a:t>
             </a:r>
-            <a:endParaRPr lang="en-US"/>
           </a:p>
         </p:txBody>
       </p:sp>
@@ -688,7 +734,7 @@
           <a:p>
             <a:fld id="{5BCAD085-E8A6-8845-BD4E-CB4CCA059FC4}" type="datetimeFigureOut">
               <a:rPr lang="en-US" smtClean="0"/>
-              <a:t>1/27/13</a:t>
+              <a:t>3/25/2026</a:t>
             </a:fld>
             <a:endParaRPr lang="en-US"/>
           </a:p>
@@ -730,7 +776,7 @@
           <a:p>
             <a:fld id="{C1FF6DA9-008F-8B48-92A6-B652298478BF}" type="slidenum">
               <a:rPr lang="en-US" smtClean="0"/>
-              <a:t>‹#›</a:t>
+              <a:t>‹nº›</a:t>
             </a:fld>
             <a:endParaRPr lang="en-US"/>
           </a:p>
@@ -787,10 +833,9 @@
           <a:lstStyle/>
           <a:p>
             <a:r>
-              <a:rPr lang="en-US" smtClean="0"/>
+              <a:rPr lang="en-US"/>
               <a:t>Click to edit Master title style</a:t>
             </a:r>
-            <a:endParaRPr lang="en-US"/>
           </a:p>
         </p:txBody>
       </p:sp>
@@ -816,38 +861,37 @@
           <a:p>
             <a:pPr lvl="0"/>
             <a:r>
-              <a:rPr lang="en-US" smtClean="0"/>
+              <a:rPr lang="en-US"/>
               <a:t>Click to edit Master text styles</a:t>
             </a:r>
           </a:p>
           <a:p>
             <a:pPr lvl="1"/>
             <a:r>
-              <a:rPr lang="en-US" smtClean="0"/>
+              <a:rPr lang="en-US"/>
               <a:t>Second level</a:t>
             </a:r>
           </a:p>
           <a:p>
             <a:pPr lvl="2"/>
             <a:r>
-              <a:rPr lang="en-US" smtClean="0"/>
+              <a:rPr lang="en-US"/>
               <a:t>Third level</a:t>
             </a:r>
           </a:p>
           <a:p>
             <a:pPr lvl="3"/>
             <a:r>
-              <a:rPr lang="en-US" smtClean="0"/>
+              <a:rPr lang="en-US"/>
               <a:t>Fourth level</a:t>
             </a:r>
           </a:p>
           <a:p>
             <a:pPr lvl="4"/>
             <a:r>
-              <a:rPr lang="en-US" smtClean="0"/>
+              <a:rPr lang="en-US"/>
               <a:t>Fifth level</a:t>
             </a:r>
-            <a:endParaRPr lang="en-US"/>
           </a:p>
         </p:txBody>
       </p:sp>
@@ -868,7 +912,7 @@
           <a:p>
             <a:fld id="{5BCAD085-E8A6-8845-BD4E-CB4CCA059FC4}" type="datetimeFigureOut">
               <a:rPr lang="en-US" smtClean="0"/>
-              <a:t>1/27/13</a:t>
+              <a:t>3/25/2026</a:t>
             </a:fld>
             <a:endParaRPr lang="en-US"/>
           </a:p>
@@ -910,7 +954,7 @@
           <a:p>
             <a:fld id="{C1FF6DA9-008F-8B48-92A6-B652298478BF}" type="slidenum">
               <a:rPr lang="en-US" smtClean="0"/>
-              <a:t>‹#›</a:t>
+              <a:t>‹nº›</a:t>
             </a:fld>
             <a:endParaRPr lang="en-US"/>
           </a:p>
@@ -962,10 +1006,9 @@
           <a:lstStyle/>
           <a:p>
             <a:r>
-              <a:rPr lang="en-US" smtClean="0"/>
+              <a:rPr lang="en-US"/>
               <a:t>Click to edit Master title style</a:t>
             </a:r>
-            <a:endParaRPr lang="en-US"/>
           </a:p>
         </p:txBody>
       </p:sp>
@@ -986,38 +1029,37 @@
           <a:p>
             <a:pPr lvl="0"/>
             <a:r>
-              <a:rPr lang="en-US" smtClean="0"/>
+              <a:rPr lang="en-US"/>
               <a:t>Click to edit Master text styles</a:t>
             </a:r>
           </a:p>
           <a:p>
             <a:pPr lvl="1"/>
             <a:r>
-              <a:rPr lang="en-US" smtClean="0"/>
+              <a:rPr lang="en-US"/>
               <a:t>Second level</a:t>
             </a:r>
           </a:p>
           <a:p>
             <a:pPr lvl="2"/>
             <a:r>
-              <a:rPr lang="en-US" smtClean="0"/>
+              <a:rPr lang="en-US"/>
               <a:t>Third level</a:t>
             </a:r>
           </a:p>
           <a:p>
             <a:pPr lvl="3"/>
             <a:r>
-              <a:rPr lang="en-US" smtClean="0"/>
+              <a:rPr lang="en-US"/>
               <a:t>Fourth level</a:t>
             </a:r>
           </a:p>
           <a:p>
             <a:pPr lvl="4"/>
             <a:r>
-              <a:rPr lang="en-US" smtClean="0"/>
+              <a:rPr lang="en-US"/>
               <a:t>Fifth level</a:t>
             </a:r>
-            <a:endParaRPr lang="en-US"/>
           </a:p>
         </p:txBody>
       </p:sp>
@@ -1038,7 +1080,7 @@
           <a:p>
             <a:fld id="{5BCAD085-E8A6-8845-BD4E-CB4CCA059FC4}" type="datetimeFigureOut">
               <a:rPr lang="en-US" smtClean="0"/>
-              <a:t>1/27/13</a:t>
+              <a:t>3/25/2026</a:t>
             </a:fld>
             <a:endParaRPr lang="en-US"/>
           </a:p>
@@ -1080,7 +1122,7 @@
           <a:p>
             <a:fld id="{C1FF6DA9-008F-8B48-92A6-B652298478BF}" type="slidenum">
               <a:rPr lang="en-US" smtClean="0"/>
-              <a:t>‹#›</a:t>
+              <a:t>‹nº›</a:t>
             </a:fld>
             <a:endParaRPr lang="en-US"/>
           </a:p>
@@ -1141,10 +1183,9 @@
           </a:lstStyle>
           <a:p>
             <a:r>
-              <a:rPr lang="en-US" smtClean="0"/>
+              <a:rPr lang="en-US"/>
               <a:t>Click to edit Master title style</a:t>
             </a:r>
-            <a:endParaRPr lang="en-US"/>
           </a:p>
         </p:txBody>
       </p:sp>
@@ -1261,7 +1302,7 @@
           <a:p>
             <a:pPr lvl="0"/>
             <a:r>
-              <a:rPr lang="en-US" smtClean="0"/>
+              <a:rPr lang="en-US"/>
               <a:t>Click to edit Master text styles</a:t>
             </a:r>
           </a:p>
@@ -1284,7 +1325,7 @@
           <a:p>
             <a:fld id="{5BCAD085-E8A6-8845-BD4E-CB4CCA059FC4}" type="datetimeFigureOut">
               <a:rPr lang="en-US" smtClean="0"/>
-              <a:t>1/27/13</a:t>
+              <a:t>3/25/2026</a:t>
             </a:fld>
             <a:endParaRPr lang="en-US"/>
           </a:p>
@@ -1326,7 +1367,7 @@
           <a:p>
             <a:fld id="{C1FF6DA9-008F-8B48-92A6-B652298478BF}" type="slidenum">
               <a:rPr lang="en-US" smtClean="0"/>
-              <a:t>‹#›</a:t>
+              <a:t>‹nº›</a:t>
             </a:fld>
             <a:endParaRPr lang="en-US"/>
           </a:p>
@@ -1378,10 +1419,9 @@
           <a:lstStyle/>
           <a:p>
             <a:r>
-              <a:rPr lang="en-US" smtClean="0"/>
+              <a:rPr lang="en-US"/>
               <a:t>Click to edit Master title style</a:t>
             </a:r>
-            <a:endParaRPr lang="en-US"/>
           </a:p>
         </p:txBody>
       </p:sp>
@@ -1435,38 +1475,37 @@
           <a:p>
             <a:pPr lvl="0"/>
             <a:r>
-              <a:rPr lang="en-US" smtClean="0"/>
+              <a:rPr lang="en-US"/>
               <a:t>Click to edit Master text styles</a:t>
             </a:r>
           </a:p>
           <a:p>
             <a:pPr lvl="1"/>
             <a:r>
-              <a:rPr lang="en-US" smtClean="0"/>
+              <a:rPr lang="en-US"/>
               <a:t>Second level</a:t>
             </a:r>
           </a:p>
           <a:p>
             <a:pPr lvl="2"/>
             <a:r>
-              <a:rPr lang="en-US" smtClean="0"/>
+              <a:rPr lang="en-US"/>
               <a:t>Third level</a:t>
             </a:r>
           </a:p>
           <a:p>
             <a:pPr lvl="3"/>
             <a:r>
-              <a:rPr lang="en-US" smtClean="0"/>
+              <a:rPr lang="en-US"/>
               <a:t>Fourth level</a:t>
             </a:r>
           </a:p>
           <a:p>
             <a:pPr lvl="4"/>
             <a:r>
-              <a:rPr lang="en-US" smtClean="0"/>
+              <a:rPr lang="en-US"/>
               <a:t>Fifth level</a:t>
             </a:r>
-            <a:endParaRPr lang="en-US"/>
           </a:p>
         </p:txBody>
       </p:sp>
@@ -1520,38 +1559,37 @@
           <a:p>
             <a:pPr lvl="0"/>
             <a:r>
-              <a:rPr lang="en-US" smtClean="0"/>
+              <a:rPr lang="en-US"/>
               <a:t>Click to edit Master text styles</a:t>
             </a:r>
           </a:p>
           <a:p>
             <a:pPr lvl="1"/>
             <a:r>
-              <a:rPr lang="en-US" smtClean="0"/>
+              <a:rPr lang="en-US"/>
               <a:t>Second level</a:t>
             </a:r>
           </a:p>
           <a:p>
             <a:pPr lvl="2"/>
             <a:r>
-              <a:rPr lang="en-US" smtClean="0"/>
+              <a:rPr lang="en-US"/>
               <a:t>Third level</a:t>
             </a:r>
           </a:p>
           <a:p>
             <a:pPr lvl="3"/>
             <a:r>
-              <a:rPr lang="en-US" smtClean="0"/>
+              <a:rPr lang="en-US"/>
               <a:t>Fourth level</a:t>
             </a:r>
           </a:p>
           <a:p>
             <a:pPr lvl="4"/>
             <a:r>
-              <a:rPr lang="en-US" smtClean="0"/>
+              <a:rPr lang="en-US"/>
               <a:t>Fifth level</a:t>
             </a:r>
-            <a:endParaRPr lang="en-US"/>
           </a:p>
         </p:txBody>
       </p:sp>
@@ -1572,7 +1610,7 @@
           <a:p>
             <a:fld id="{5BCAD085-E8A6-8845-BD4E-CB4CCA059FC4}" type="datetimeFigureOut">
               <a:rPr lang="en-US" smtClean="0"/>
-              <a:t>1/27/13</a:t>
+              <a:t>3/25/2026</a:t>
             </a:fld>
             <a:endParaRPr lang="en-US"/>
           </a:p>
@@ -1614,7 +1652,7 @@
           <a:p>
             <a:fld id="{C1FF6DA9-008F-8B48-92A6-B652298478BF}" type="slidenum">
               <a:rPr lang="en-US" smtClean="0"/>
-              <a:t>‹#›</a:t>
+              <a:t>‹nº›</a:t>
             </a:fld>
             <a:endParaRPr lang="en-US"/>
           </a:p>
@@ -1670,10 +1708,9 @@
           </a:lstStyle>
           <a:p>
             <a:r>
-              <a:rPr lang="en-US" smtClean="0"/>
+              <a:rPr lang="en-US"/>
               <a:t>Click to edit Master title style</a:t>
             </a:r>
-            <a:endParaRPr lang="en-US"/>
           </a:p>
         </p:txBody>
       </p:sp>
@@ -1736,7 +1773,7 @@
           <a:p>
             <a:pPr lvl="0"/>
             <a:r>
-              <a:rPr lang="en-US" smtClean="0"/>
+              <a:rPr lang="en-US"/>
               <a:t>Click to edit Master text styles</a:t>
             </a:r>
           </a:p>
@@ -1792,38 +1829,37 @@
           <a:p>
             <a:pPr lvl="0"/>
             <a:r>
-              <a:rPr lang="en-US" smtClean="0"/>
+              <a:rPr lang="en-US"/>
               <a:t>Click to edit Master text styles</a:t>
             </a:r>
           </a:p>
           <a:p>
             <a:pPr lvl="1"/>
             <a:r>
-              <a:rPr lang="en-US" smtClean="0"/>
+              <a:rPr lang="en-US"/>
               <a:t>Second level</a:t>
             </a:r>
           </a:p>
           <a:p>
             <a:pPr lvl="2"/>
             <a:r>
-              <a:rPr lang="en-US" smtClean="0"/>
+              <a:rPr lang="en-US"/>
               <a:t>Third level</a:t>
             </a:r>
           </a:p>
           <a:p>
             <a:pPr lvl="3"/>
             <a:r>
-              <a:rPr lang="en-US" smtClean="0"/>
+              <a:rPr lang="en-US"/>
               <a:t>Fourth level</a:t>
             </a:r>
           </a:p>
           <a:p>
             <a:pPr lvl="4"/>
             <a:r>
-              <a:rPr lang="en-US" smtClean="0"/>
+              <a:rPr lang="en-US"/>
               <a:t>Fifth level</a:t>
             </a:r>
-            <a:endParaRPr lang="en-US"/>
           </a:p>
         </p:txBody>
       </p:sp>
@@ -1886,7 +1922,7 @@
           <a:p>
             <a:pPr lvl="0"/>
             <a:r>
-              <a:rPr lang="en-US" smtClean="0"/>
+              <a:rPr lang="en-US"/>
               <a:t>Click to edit Master text styles</a:t>
             </a:r>
           </a:p>
@@ -1942,38 +1978,37 @@
           <a:p>
             <a:pPr lvl="0"/>
             <a:r>
-              <a:rPr lang="en-US" smtClean="0"/>
+              <a:rPr lang="en-US"/>
               <a:t>Click to edit Master text styles</a:t>
             </a:r>
           </a:p>
           <a:p>
             <a:pPr lvl="1"/>
             <a:r>
-              <a:rPr lang="en-US" smtClean="0"/>
+              <a:rPr lang="en-US"/>
               <a:t>Second level</a:t>
             </a:r>
           </a:p>
           <a:p>
             <a:pPr lvl="2"/>
             <a:r>
-              <a:rPr lang="en-US" smtClean="0"/>
+              <a:rPr lang="en-US"/>
               <a:t>Third level</a:t>
             </a:r>
           </a:p>
           <a:p>
             <a:pPr lvl="3"/>
             <a:r>
-              <a:rPr lang="en-US" smtClean="0"/>
+              <a:rPr lang="en-US"/>
               <a:t>Fourth level</a:t>
             </a:r>
           </a:p>
           <a:p>
             <a:pPr lvl="4"/>
             <a:r>
-              <a:rPr lang="en-US" smtClean="0"/>
+              <a:rPr lang="en-US"/>
               <a:t>Fifth level</a:t>
             </a:r>
-            <a:endParaRPr lang="en-US"/>
           </a:p>
         </p:txBody>
       </p:sp>
@@ -1994,7 +2029,7 @@
           <a:p>
             <a:fld id="{5BCAD085-E8A6-8845-BD4E-CB4CCA059FC4}" type="datetimeFigureOut">
               <a:rPr lang="en-US" smtClean="0"/>
-              <a:t>1/27/13</a:t>
+              <a:t>3/25/2026</a:t>
             </a:fld>
             <a:endParaRPr lang="en-US"/>
           </a:p>
@@ -2036,7 +2071,7 @@
           <a:p>
             <a:fld id="{C1FF6DA9-008F-8B48-92A6-B652298478BF}" type="slidenum">
               <a:rPr lang="en-US" smtClean="0"/>
-              <a:t>‹#›</a:t>
+              <a:t>‹nº›</a:t>
             </a:fld>
             <a:endParaRPr lang="en-US"/>
           </a:p>
@@ -2088,10 +2123,9 @@
           <a:lstStyle/>
           <a:p>
             <a:r>
-              <a:rPr lang="en-US" smtClean="0"/>
+              <a:rPr lang="en-US"/>
               <a:t>Click to edit Master title style</a:t>
             </a:r>
-            <a:endParaRPr lang="en-US"/>
           </a:p>
         </p:txBody>
       </p:sp>
@@ -2112,7 +2146,7 @@
           <a:p>
             <a:fld id="{5BCAD085-E8A6-8845-BD4E-CB4CCA059FC4}" type="datetimeFigureOut">
               <a:rPr lang="en-US" smtClean="0"/>
-              <a:t>1/27/13</a:t>
+              <a:t>3/25/2026</a:t>
             </a:fld>
             <a:endParaRPr lang="en-US"/>
           </a:p>
@@ -2154,7 +2188,7 @@
           <a:p>
             <a:fld id="{C1FF6DA9-008F-8B48-92A6-B652298478BF}" type="slidenum">
               <a:rPr lang="en-US" smtClean="0"/>
-              <a:t>‹#›</a:t>
+              <a:t>‹nº›</a:t>
             </a:fld>
             <a:endParaRPr lang="en-US"/>
           </a:p>
@@ -2207,7 +2241,7 @@
           <a:p>
             <a:fld id="{5BCAD085-E8A6-8845-BD4E-CB4CCA059FC4}" type="datetimeFigureOut">
               <a:rPr lang="en-US" smtClean="0"/>
-              <a:t>1/27/13</a:t>
+              <a:t>3/25/2026</a:t>
             </a:fld>
             <a:endParaRPr lang="en-US"/>
           </a:p>
@@ -2249,7 +2283,7 @@
           <a:p>
             <a:fld id="{C1FF6DA9-008F-8B48-92A6-B652298478BF}" type="slidenum">
               <a:rPr lang="en-US" smtClean="0"/>
-              <a:t>‹#›</a:t>
+              <a:t>‹nº›</a:t>
             </a:fld>
             <a:endParaRPr lang="en-US"/>
           </a:p>
@@ -2310,10 +2344,9 @@
           </a:lstStyle>
           <a:p>
             <a:r>
-              <a:rPr lang="en-US" smtClean="0"/>
+              <a:rPr lang="en-US"/>
               <a:t>Click to edit Master title style</a:t>
             </a:r>
-            <a:endParaRPr lang="en-US"/>
           </a:p>
         </p:txBody>
       </p:sp>
@@ -2367,38 +2400,37 @@
           <a:p>
             <a:pPr lvl="0"/>
             <a:r>
-              <a:rPr lang="en-US" smtClean="0"/>
+              <a:rPr lang="en-US"/>
               <a:t>Click to edit Master text styles</a:t>
             </a:r>
           </a:p>
           <a:p>
             <a:pPr lvl="1"/>
             <a:r>
-              <a:rPr lang="en-US" smtClean="0"/>
+              <a:rPr lang="en-US"/>
               <a:t>Second level</a:t>
             </a:r>
           </a:p>
           <a:p>
             <a:pPr lvl="2"/>
             <a:r>
-              <a:rPr lang="en-US" smtClean="0"/>
+              <a:rPr lang="en-US"/>
               <a:t>Third level</a:t>
             </a:r>
           </a:p>
           <a:p>
             <a:pPr lvl="3"/>
             <a:r>
-              <a:rPr lang="en-US" smtClean="0"/>
+              <a:rPr lang="en-US"/>
               <a:t>Fourth level</a:t>
             </a:r>
           </a:p>
           <a:p>
             <a:pPr lvl="4"/>
             <a:r>
-              <a:rPr lang="en-US" smtClean="0"/>
+              <a:rPr lang="en-US"/>
               <a:t>Fifth level</a:t>
             </a:r>
-            <a:endParaRPr lang="en-US"/>
           </a:p>
         </p:txBody>
       </p:sp>
@@ -2461,7 +2493,7 @@
           <a:p>
             <a:pPr lvl="0"/>
             <a:r>
-              <a:rPr lang="en-US" smtClean="0"/>
+              <a:rPr lang="en-US"/>
               <a:t>Click to edit Master text styles</a:t>
             </a:r>
           </a:p>
@@ -2484,7 +2516,7 @@
           <a:p>
             <a:fld id="{5BCAD085-E8A6-8845-BD4E-CB4CCA059FC4}" type="datetimeFigureOut">
               <a:rPr lang="en-US" smtClean="0"/>
-              <a:t>1/27/13</a:t>
+              <a:t>3/25/2026</a:t>
             </a:fld>
             <a:endParaRPr lang="en-US"/>
           </a:p>
@@ -2526,7 +2558,7 @@
           <a:p>
             <a:fld id="{C1FF6DA9-008F-8B48-92A6-B652298478BF}" type="slidenum">
               <a:rPr lang="en-US" smtClean="0"/>
-              <a:t>‹#›</a:t>
+              <a:t>‹nº›</a:t>
             </a:fld>
             <a:endParaRPr lang="en-US"/>
           </a:p>
@@ -2587,10 +2619,9 @@
           </a:lstStyle>
           <a:p>
             <a:r>
-              <a:rPr lang="en-US" smtClean="0"/>
+              <a:rPr lang="en-US"/>
               <a:t>Click to edit Master title style</a:t>
             </a:r>
-            <a:endParaRPr lang="en-US"/>
           </a:p>
         </p:txBody>
       </p:sp>
@@ -2714,7 +2745,7 @@
           <a:p>
             <a:pPr lvl="0"/>
             <a:r>
-              <a:rPr lang="en-US" smtClean="0"/>
+              <a:rPr lang="en-US"/>
               <a:t>Click to edit Master text styles</a:t>
             </a:r>
           </a:p>
@@ -2737,7 +2768,7 @@
           <a:p>
             <a:fld id="{5BCAD085-E8A6-8845-BD4E-CB4CCA059FC4}" type="datetimeFigureOut">
               <a:rPr lang="en-US" smtClean="0"/>
-              <a:t>1/27/13</a:t>
+              <a:t>3/25/2026</a:t>
             </a:fld>
             <a:endParaRPr lang="en-US"/>
           </a:p>
@@ -2779,7 +2810,7 @@
           <a:p>
             <a:fld id="{C1FF6DA9-008F-8B48-92A6-B652298478BF}" type="slidenum">
               <a:rPr lang="en-US" smtClean="0"/>
-              <a:t>‹#›</a:t>
+              <a:t>‹nº›</a:t>
             </a:fld>
             <a:endParaRPr lang="en-US"/>
           </a:p>
@@ -2846,10 +2877,9 @@
           <a:lstStyle/>
           <a:p>
             <a:r>
-              <a:rPr lang="en-US" smtClean="0"/>
+              <a:rPr lang="en-US"/>
               <a:t>Click to edit Master title style</a:t>
             </a:r>
-            <a:endParaRPr lang="en-US"/>
           </a:p>
         </p:txBody>
       </p:sp>
@@ -2880,38 +2910,37 @@
           <a:p>
             <a:pPr lvl="0"/>
             <a:r>
-              <a:rPr lang="en-US" smtClean="0"/>
+              <a:rPr lang="en-US"/>
               <a:t>Click to edit Master text styles</a:t>
             </a:r>
           </a:p>
           <a:p>
             <a:pPr lvl="1"/>
             <a:r>
-              <a:rPr lang="en-US" smtClean="0"/>
+              <a:rPr lang="en-US"/>
               <a:t>Second level</a:t>
             </a:r>
           </a:p>
           <a:p>
             <a:pPr lvl="2"/>
             <a:r>
-              <a:rPr lang="en-US" smtClean="0"/>
+              <a:rPr lang="en-US"/>
               <a:t>Third level</a:t>
             </a:r>
           </a:p>
           <a:p>
             <a:pPr lvl="3"/>
             <a:r>
-              <a:rPr lang="en-US" smtClean="0"/>
+              <a:rPr lang="en-US"/>
               <a:t>Fourth level</a:t>
             </a:r>
           </a:p>
           <a:p>
             <a:pPr lvl="4"/>
             <a:r>
-              <a:rPr lang="en-US" smtClean="0"/>
+              <a:rPr lang="en-US"/>
               <a:t>Fifth level</a:t>
             </a:r>
-            <a:endParaRPr lang="en-US"/>
           </a:p>
         </p:txBody>
       </p:sp>
@@ -2950,7 +2979,7 @@
           <a:p>
             <a:fld id="{5BCAD085-E8A6-8845-BD4E-CB4CCA059FC4}" type="datetimeFigureOut">
               <a:rPr lang="en-US" smtClean="0"/>
-              <a:t>1/27/13</a:t>
+              <a:t>3/25/2026</a:t>
             </a:fld>
             <a:endParaRPr lang="en-US"/>
           </a:p>
@@ -3028,7 +3057,7 @@
           <a:p>
             <a:fld id="{C1FF6DA9-008F-8B48-92A6-B652298478BF}" type="slidenum">
               <a:rPr lang="en-US" smtClean="0"/>
-              <a:t>‹#›</a:t>
+              <a:t>‹nº›</a:t>
             </a:fld>
             <a:endParaRPr lang="en-US"/>
           </a:p>
@@ -3309,7 +3338,7 @@
 </file>
 
 <file path=ppt/slides/slide1.xml><?xml version="1.0" encoding="utf-8"?>
-<p:sld xmlns:a="http://schemas.openxmlformats.org/drawingml/2006/main" xmlns:p="http://schemas.openxmlformats.org/presentationml/2006/main" xmlns:r="http://schemas.openxmlformats.org/officeDocument/2006/relationships">
+<p:sld xmlns:a="http://schemas.openxmlformats.org/drawingml/2006/main" xmlns:r="http://schemas.openxmlformats.org/officeDocument/2006/relationships" xmlns:p="http://schemas.openxmlformats.org/presentationml/2006/main">
   <p:cSld>
     <p:spTree>
       <p:nvGrpSpPr>
@@ -3317,7 +3346,14 @@
         <p:cNvGrpSpPr/>
         <p:nvPr/>
       </p:nvGrpSpPr>
-      <p:grpSpPr/>
+      <p:grpSpPr>
+        <a:xfrm>
+          <a:off x="0" y="0"/>
+          <a:ext cx="0" cy="0"/>
+          <a:chOff x="0" y="0"/>
+          <a:chExt cx="0" cy="0"/>
+        </a:xfrm>
+      </p:grpSpPr>
       <p:sp>
         <p:nvSpPr>
           <p:cNvPr id="2" name="Title 1"/>
@@ -3334,7 +3370,6 @@
           <a:lstStyle/>
           <a:p>
             <a:r>
-              <a:rPr/>
               <a:t>Análise de Tarifas de Intercâmbio e Estatísticas de Pagamentos</a:t>
             </a:r>
           </a:p>
@@ -3356,7 +3391,6 @@
           <a:lstStyle/>
           <a:p>
             <a:r>
-              <a:rPr/>
               <a:t>Comparação entre Visa, Mastercard e dados do Banco Central (BCB), 2023</a:t>
             </a:r>
           </a:p>
@@ -3395,7 +3429,7 @@
 </file>
 
 <file path=ppt/slides/slide10.xml><?xml version="1.0" encoding="utf-8"?>
-<p:sld xmlns:a="http://schemas.openxmlformats.org/drawingml/2006/main" xmlns:p="http://schemas.openxmlformats.org/presentationml/2006/main" xmlns:r="http://schemas.openxmlformats.org/officeDocument/2006/relationships">
+<p:sld xmlns:a="http://schemas.openxmlformats.org/drawingml/2006/main" xmlns:r="http://schemas.openxmlformats.org/officeDocument/2006/relationships" xmlns:p="http://schemas.openxmlformats.org/presentationml/2006/main">
   <p:cSld>
     <p:spTree>
       <p:nvGrpSpPr>
@@ -3403,7 +3437,14 @@
         <p:cNvGrpSpPr/>
         <p:nvPr/>
       </p:nvGrpSpPr>
-      <p:grpSpPr/>
+      <p:grpSpPr>
+        <a:xfrm>
+          <a:off x="0" y="0"/>
+          <a:ext cx="0" cy="0"/>
+          <a:chOff x="0" y="0"/>
+          <a:chExt cx="0" cy="0"/>
+        </a:xfrm>
+      </p:grpSpPr>
       <p:sp>
         <p:nvSpPr>
           <p:cNvPr id="2" name="Title 1"/>
@@ -3420,7 +3461,6 @@
           <a:lstStyle/>
           <a:p>
             <a:r>
-              <a:rPr/>
               <a:t>Conclusões e Recomendações</a:t>
             </a:r>
           </a:p>
@@ -3436,44 +3476,532 @@
             <p:ph idx="1"/>
           </p:nvPr>
         </p:nvSpPr>
-        <p:spPr/>
-        <p:txBody>
-          <a:bodyPr/>
+        <p:spPr>
+          <a:xfrm>
+            <a:off x="457200" y="1417638"/>
+            <a:ext cx="8229600" cy="4525963"/>
+          </a:xfrm>
+        </p:spPr>
+        <p:txBody>
+          <a:bodyPr>
+            <a:normAutofit fontScale="62500" lnSpcReduction="20000"/>
+          </a:bodyPr>
           <a:lstStyle/>
-          <a:p/>
-          <a:p>
-            <a:pPr/>
-            <a:r>
-              <a:rPr/>
-              <a:t>Visa e Mastercard praticam estruturas de intercâmbio semelhantes: taxas base diferenciadas por categoria/tier de cartão e ajustes para canais e parcelamentos.</a:t>
-            </a:r>
-          </a:p>
-          <a:p>
-            <a:pPr/>
-            <a:r>
-              <a:rPr/>
-              <a:t>As taxas da Mastercard tendem a apresentar maior granularidade por segmento e níveis mais elevados para categorias premium (Black, World Legend).</a:t>
-            </a:r>
-          </a:p>
-          <a:p>
-            <a:pPr/>
-            <a:r>
-              <a:rPr/>
-              <a:t>A Resolução BCB nº 246/2022 impõe limites rígidos para débito (0,5%) e pré‑pago (0,7%), pressionando a redução das tarifas e estimulando competitividade.</a:t>
-            </a:r>
-          </a:p>
-          <a:p>
-            <a:pPr/>
-            <a:r>
-              <a:rPr/>
-              <a:t>O crescimento acelerado do Pix e do pré‑pago exige que emissores e adquirentes adaptem estratégias – oferecendo incentivos ao uso de meios eletrônicos de baixo custo.</a:t>
-            </a:r>
-          </a:p>
-          <a:p>
-            <a:pPr/>
-            <a:r>
-              <a:rPr/>
-              <a:t>Recomenda-se investir em automação de coleta de dados (OCR e NLP) para atualizações periódicas e monitorar consultas públicas do BC sobre limites de crédito (previstas para 2026).</a:t>
+          <a:p>
+            <a:endParaRPr dirty="0"/>
+          </a:p>
+          <a:p>
+            <a:r>
+              <a:rPr dirty="0"/>
+              <a:t>Visa e Mastercard </a:t>
+            </a:r>
+            <a:r>
+              <a:rPr dirty="0" err="1"/>
+              <a:t>praticam</a:t>
+            </a:r>
+            <a:r>
+              <a:rPr dirty="0"/>
+              <a:t> </a:t>
+            </a:r>
+            <a:r>
+              <a:rPr dirty="0" err="1"/>
+              <a:t>estruturas</a:t>
+            </a:r>
+            <a:r>
+              <a:rPr dirty="0"/>
+              <a:t> de </a:t>
+            </a:r>
+            <a:r>
+              <a:rPr dirty="0" err="1"/>
+              <a:t>intercâmbio</a:t>
+            </a:r>
+            <a:r>
+              <a:rPr dirty="0"/>
+              <a:t> </a:t>
+            </a:r>
+            <a:r>
+              <a:rPr dirty="0" err="1"/>
+              <a:t>semelhantes</a:t>
+            </a:r>
+            <a:r>
+              <a:rPr dirty="0"/>
+              <a:t>: </a:t>
+            </a:r>
+            <a:r>
+              <a:rPr dirty="0" err="1"/>
+              <a:t>taxas</a:t>
+            </a:r>
+            <a:r>
+              <a:rPr dirty="0"/>
+              <a:t> base </a:t>
+            </a:r>
+            <a:r>
+              <a:rPr dirty="0" err="1"/>
+              <a:t>diferenciadas</a:t>
+            </a:r>
+            <a:r>
+              <a:rPr dirty="0"/>
+              <a:t> por </a:t>
+            </a:r>
+            <a:r>
+              <a:rPr dirty="0" err="1"/>
+              <a:t>categoria</a:t>
+            </a:r>
+            <a:r>
+              <a:rPr dirty="0"/>
+              <a:t>/tier de </a:t>
+            </a:r>
+            <a:r>
+              <a:rPr dirty="0" err="1"/>
+              <a:t>cartão</a:t>
+            </a:r>
+            <a:r>
+              <a:rPr dirty="0"/>
+              <a:t> e </a:t>
+            </a:r>
+            <a:r>
+              <a:rPr dirty="0" err="1"/>
+              <a:t>ajustes</a:t>
+            </a:r>
+            <a:r>
+              <a:rPr dirty="0"/>
+              <a:t> para </a:t>
+            </a:r>
+            <a:r>
+              <a:rPr dirty="0" err="1"/>
+              <a:t>canais</a:t>
+            </a:r>
+            <a:r>
+              <a:rPr dirty="0"/>
+              <a:t> e </a:t>
+            </a:r>
+            <a:r>
+              <a:rPr dirty="0" err="1"/>
+              <a:t>parcelamentos</a:t>
+            </a:r>
+            <a:r>
+              <a:rPr dirty="0"/>
+              <a:t>.</a:t>
+            </a:r>
+          </a:p>
+          <a:p>
+            <a:r>
+              <a:rPr dirty="0"/>
+              <a:t>As </a:t>
+            </a:r>
+            <a:r>
+              <a:rPr dirty="0" err="1"/>
+              <a:t>taxas</a:t>
+            </a:r>
+            <a:r>
+              <a:rPr dirty="0"/>
+              <a:t> da Mastercard </a:t>
+            </a:r>
+            <a:r>
+              <a:rPr dirty="0" err="1"/>
+              <a:t>tendem</a:t>
+            </a:r>
+            <a:r>
+              <a:rPr dirty="0"/>
+              <a:t> a </a:t>
+            </a:r>
+            <a:r>
+              <a:rPr dirty="0" err="1"/>
+              <a:t>apresentar</a:t>
+            </a:r>
+            <a:r>
+              <a:rPr dirty="0"/>
+              <a:t> </a:t>
+            </a:r>
+            <a:r>
+              <a:rPr dirty="0" err="1"/>
+              <a:t>maior</a:t>
+            </a:r>
+            <a:r>
+              <a:rPr dirty="0"/>
+              <a:t> </a:t>
+            </a:r>
+            <a:r>
+              <a:rPr dirty="0" err="1"/>
+              <a:t>granularidade</a:t>
+            </a:r>
+            <a:r>
+              <a:rPr dirty="0"/>
+              <a:t> por </a:t>
+            </a:r>
+            <a:r>
+              <a:rPr dirty="0" err="1"/>
+              <a:t>segmento</a:t>
+            </a:r>
+            <a:r>
+              <a:rPr dirty="0"/>
+              <a:t> e </a:t>
+            </a:r>
+            <a:r>
+              <a:rPr dirty="0" err="1"/>
+              <a:t>níveis</a:t>
+            </a:r>
+            <a:r>
+              <a:rPr dirty="0"/>
+              <a:t> </a:t>
+            </a:r>
+            <a:r>
+              <a:rPr dirty="0" err="1"/>
+              <a:t>mais</a:t>
+            </a:r>
+            <a:r>
+              <a:rPr dirty="0"/>
+              <a:t> </a:t>
+            </a:r>
+            <a:r>
+              <a:rPr dirty="0" err="1"/>
+              <a:t>elevados</a:t>
+            </a:r>
+            <a:r>
+              <a:rPr dirty="0"/>
+              <a:t> para </a:t>
+            </a:r>
+            <a:r>
+              <a:rPr dirty="0" err="1"/>
+              <a:t>categorias</a:t>
+            </a:r>
+            <a:r>
+              <a:rPr dirty="0"/>
+              <a:t> premium (Black, World Legend).</a:t>
+            </a:r>
+          </a:p>
+          <a:p>
+            <a:r>
+              <a:rPr dirty="0"/>
+              <a:t>A </a:t>
+            </a:r>
+            <a:r>
+              <a:rPr dirty="0" err="1"/>
+              <a:t>Resolução</a:t>
+            </a:r>
+            <a:r>
+              <a:rPr dirty="0"/>
+              <a:t> BCB nº 246/2022 </a:t>
+            </a:r>
+            <a:r>
+              <a:rPr dirty="0" err="1"/>
+              <a:t>impõe</a:t>
+            </a:r>
+            <a:r>
+              <a:rPr dirty="0"/>
+              <a:t> </a:t>
+            </a:r>
+            <a:r>
+              <a:rPr dirty="0" err="1"/>
+              <a:t>limites</a:t>
+            </a:r>
+            <a:r>
+              <a:rPr dirty="0"/>
+              <a:t> </a:t>
+            </a:r>
+            <a:r>
+              <a:rPr dirty="0" err="1"/>
+              <a:t>rígidos</a:t>
+            </a:r>
+            <a:r>
+              <a:rPr dirty="0"/>
+              <a:t> para </a:t>
+            </a:r>
+            <a:r>
+              <a:rPr dirty="0" err="1"/>
+              <a:t>débito</a:t>
+            </a:r>
+            <a:r>
+              <a:rPr dirty="0"/>
+              <a:t> (0,5%) e </a:t>
+            </a:r>
+            <a:r>
+              <a:rPr dirty="0" err="1"/>
+              <a:t>pré‑pago</a:t>
+            </a:r>
+            <a:r>
+              <a:rPr dirty="0"/>
+              <a:t> (0,7%), </a:t>
+            </a:r>
+            <a:r>
+              <a:rPr dirty="0" err="1"/>
+              <a:t>pressionando</a:t>
+            </a:r>
+            <a:r>
+              <a:rPr dirty="0"/>
+              <a:t> a </a:t>
+            </a:r>
+            <a:r>
+              <a:rPr dirty="0" err="1"/>
+              <a:t>redução</a:t>
+            </a:r>
+            <a:r>
+              <a:rPr dirty="0"/>
+              <a:t> das </a:t>
+            </a:r>
+            <a:r>
+              <a:rPr dirty="0" err="1"/>
+              <a:t>tarifas</a:t>
+            </a:r>
+            <a:r>
+              <a:rPr dirty="0"/>
+              <a:t> e </a:t>
+            </a:r>
+            <a:r>
+              <a:rPr dirty="0" err="1"/>
+              <a:t>estimulando</a:t>
+            </a:r>
+            <a:r>
+              <a:rPr dirty="0"/>
+              <a:t> </a:t>
+            </a:r>
+            <a:r>
+              <a:rPr dirty="0" err="1"/>
+              <a:t>competitividade</a:t>
+            </a:r>
+            <a:r>
+              <a:rPr dirty="0"/>
+              <a:t>.</a:t>
+            </a:r>
+          </a:p>
+          <a:p>
+            <a:r>
+              <a:rPr dirty="0"/>
+              <a:t>O </a:t>
+            </a:r>
+            <a:r>
+              <a:rPr dirty="0" err="1"/>
+              <a:t>crescimento</a:t>
+            </a:r>
+            <a:r>
+              <a:rPr dirty="0"/>
+              <a:t> </a:t>
+            </a:r>
+            <a:r>
+              <a:rPr dirty="0" err="1"/>
+              <a:t>acelerado</a:t>
+            </a:r>
+            <a:r>
+              <a:rPr dirty="0"/>
+              <a:t> do Pix e do </a:t>
+            </a:r>
+            <a:r>
+              <a:rPr dirty="0" err="1"/>
+              <a:t>pré‑pago</a:t>
+            </a:r>
+            <a:r>
+              <a:rPr dirty="0"/>
+              <a:t> </a:t>
+            </a:r>
+            <a:r>
+              <a:rPr dirty="0" err="1"/>
+              <a:t>exige</a:t>
+            </a:r>
+            <a:r>
+              <a:rPr dirty="0"/>
+              <a:t> que </a:t>
+            </a:r>
+            <a:r>
+              <a:rPr dirty="0" err="1"/>
+              <a:t>emissores</a:t>
+            </a:r>
+            <a:r>
+              <a:rPr dirty="0"/>
+              <a:t> e </a:t>
+            </a:r>
+            <a:r>
+              <a:rPr dirty="0" err="1"/>
+              <a:t>adquirentes</a:t>
+            </a:r>
+            <a:r>
+              <a:rPr dirty="0"/>
+              <a:t> </a:t>
+            </a:r>
+            <a:r>
+              <a:rPr dirty="0" err="1"/>
+              <a:t>adaptem</a:t>
+            </a:r>
+            <a:r>
+              <a:rPr dirty="0"/>
+              <a:t> </a:t>
+            </a:r>
+            <a:r>
+              <a:rPr dirty="0" err="1"/>
+              <a:t>estratégias</a:t>
+            </a:r>
+            <a:r>
+              <a:rPr dirty="0"/>
+              <a:t> – </a:t>
+            </a:r>
+            <a:r>
+              <a:rPr dirty="0" err="1"/>
+              <a:t>oferecendo</a:t>
+            </a:r>
+            <a:r>
+              <a:rPr dirty="0"/>
+              <a:t> </a:t>
+            </a:r>
+            <a:r>
+              <a:rPr dirty="0" err="1"/>
+              <a:t>incentivos</a:t>
+            </a:r>
+            <a:r>
+              <a:rPr dirty="0"/>
+              <a:t> </a:t>
+            </a:r>
+            <a:r>
+              <a:rPr dirty="0" err="1"/>
+              <a:t>ao</a:t>
+            </a:r>
+            <a:r>
+              <a:rPr dirty="0"/>
+              <a:t> </a:t>
+            </a:r>
+            <a:r>
+              <a:rPr dirty="0" err="1"/>
+              <a:t>uso</a:t>
+            </a:r>
+            <a:r>
+              <a:rPr dirty="0"/>
+              <a:t> de </a:t>
+            </a:r>
+            <a:r>
+              <a:rPr dirty="0" err="1"/>
+              <a:t>meios</a:t>
+            </a:r>
+            <a:r>
+              <a:rPr dirty="0"/>
+              <a:t> </a:t>
+            </a:r>
+            <a:r>
+              <a:rPr dirty="0" err="1"/>
+              <a:t>eletrônicos</a:t>
+            </a:r>
+            <a:r>
+              <a:rPr dirty="0"/>
+              <a:t> de </a:t>
+            </a:r>
+            <a:r>
+              <a:rPr dirty="0" err="1"/>
+              <a:t>baixo</a:t>
+            </a:r>
+            <a:r>
+              <a:rPr dirty="0"/>
+              <a:t> </a:t>
+            </a:r>
+            <a:r>
+              <a:rPr dirty="0" err="1"/>
+              <a:t>custo</a:t>
+            </a:r>
+            <a:r>
+              <a:rPr dirty="0"/>
+              <a:t>.</a:t>
+            </a:r>
+          </a:p>
+          <a:p>
+            <a:r>
+              <a:rPr dirty="0" err="1"/>
+              <a:t>Recomenda</a:t>
+            </a:r>
+            <a:r>
+              <a:rPr dirty="0"/>
+              <a:t>-se </a:t>
+            </a:r>
+            <a:r>
+              <a:rPr dirty="0" err="1"/>
+              <a:t>investir</a:t>
+            </a:r>
+            <a:r>
+              <a:rPr dirty="0"/>
+              <a:t> </a:t>
+            </a:r>
+            <a:r>
+              <a:rPr dirty="0" err="1"/>
+              <a:t>em</a:t>
+            </a:r>
+            <a:r>
+              <a:rPr dirty="0"/>
+              <a:t> </a:t>
+            </a:r>
+            <a:r>
+              <a:rPr dirty="0" err="1"/>
+              <a:t>automação</a:t>
+            </a:r>
+            <a:r>
+              <a:rPr dirty="0"/>
+              <a:t> de coleta de dados (OCR e NLP) para </a:t>
+            </a:r>
+            <a:r>
+              <a:rPr dirty="0" err="1"/>
+              <a:t>atualizações</a:t>
+            </a:r>
+            <a:r>
+              <a:rPr dirty="0"/>
+              <a:t> </a:t>
+            </a:r>
+            <a:r>
+              <a:rPr dirty="0" err="1"/>
+              <a:t>periódicas</a:t>
+            </a:r>
+            <a:r>
+              <a:rPr dirty="0"/>
+              <a:t> e </a:t>
+            </a:r>
+            <a:r>
+              <a:rPr dirty="0" err="1"/>
+              <a:t>monitorar</a:t>
+            </a:r>
+            <a:r>
+              <a:rPr dirty="0"/>
+              <a:t> </a:t>
+            </a:r>
+            <a:r>
+              <a:rPr dirty="0" err="1"/>
+              <a:t>consultas</a:t>
+            </a:r>
+            <a:r>
+              <a:rPr dirty="0"/>
+              <a:t> </a:t>
+            </a:r>
+            <a:r>
+              <a:rPr dirty="0" err="1"/>
+              <a:t>públicas</a:t>
+            </a:r>
+            <a:r>
+              <a:rPr dirty="0"/>
+              <a:t> do BC </a:t>
+            </a:r>
+            <a:r>
+              <a:rPr dirty="0" err="1"/>
+              <a:t>sobre</a:t>
+            </a:r>
+            <a:r>
+              <a:rPr dirty="0"/>
+              <a:t> </a:t>
+            </a:r>
+            <a:r>
+              <a:rPr dirty="0" err="1"/>
+              <a:t>limites</a:t>
+            </a:r>
+            <a:r>
+              <a:rPr dirty="0"/>
+              <a:t> de </a:t>
+            </a:r>
+            <a:r>
+              <a:rPr dirty="0" err="1"/>
+              <a:t>crédito</a:t>
+            </a:r>
+            <a:r>
+              <a:rPr dirty="0"/>
+              <a:t> (</a:t>
+            </a:r>
+            <a:r>
+              <a:rPr dirty="0" err="1"/>
+              <a:t>previstas</a:t>
+            </a:r>
+            <a:r>
+              <a:rPr dirty="0"/>
+              <a:t> para 2026).</a:t>
             </a:r>
           </a:p>
         </p:txBody>
@@ -3487,7 +4015,7 @@
 </file>
 
 <file path=ppt/slides/slide2.xml><?xml version="1.0" encoding="utf-8"?>
-<p:sld xmlns:a="http://schemas.openxmlformats.org/drawingml/2006/main" xmlns:p="http://schemas.openxmlformats.org/presentationml/2006/main" xmlns:r="http://schemas.openxmlformats.org/officeDocument/2006/relationships">
+<p:sld xmlns:a="http://schemas.openxmlformats.org/drawingml/2006/main" xmlns:r="http://schemas.openxmlformats.org/officeDocument/2006/relationships" xmlns:p="http://schemas.openxmlformats.org/presentationml/2006/main">
   <p:cSld>
     <p:spTree>
       <p:nvGrpSpPr>
@@ -3495,7 +4023,14 @@
         <p:cNvGrpSpPr/>
         <p:nvPr/>
       </p:nvGrpSpPr>
-      <p:grpSpPr/>
+      <p:grpSpPr>
+        <a:xfrm>
+          <a:off x="0" y="0"/>
+          <a:ext cx="0" cy="0"/>
+          <a:chOff x="0" y="0"/>
+          <a:chExt cx="0" cy="0"/>
+        </a:xfrm>
+      </p:grpSpPr>
       <p:sp>
         <p:nvSpPr>
           <p:cNvPr id="2" name="Title 1"/>
@@ -3512,7 +4047,6 @@
           <a:lstStyle/>
           <a:p>
             <a:r>
-              <a:rPr/>
               <a:t>Agenda</a:t>
             </a:r>
           </a:p>
@@ -3532,46 +4066,36 @@
         <p:txBody>
           <a:bodyPr/>
           <a:lstStyle/>
-          <a:p/>
-          <a:p>
-            <a:pPr/>
-            <a:r>
-              <a:rPr/>
+          <a:p>
+            <a:endParaRPr/>
+          </a:p>
+          <a:p>
+            <a:r>
               <a:t>Visão geral do desafio e objetivo</a:t>
             </a:r>
           </a:p>
           <a:p>
-            <a:pPr/>
-            <a:r>
-              <a:rPr/>
+            <a:r>
               <a:t>Metodologia de extração de dados</a:t>
             </a:r>
           </a:p>
           <a:p>
-            <a:pPr/>
-            <a:r>
-              <a:rPr/>
+            <a:r>
               <a:t>Resumo das tarifas de intercâmbio (Visa &amp; Mastercard)</a:t>
             </a:r>
           </a:p>
           <a:p>
-            <a:pPr/>
-            <a:r>
-              <a:rPr/>
+            <a:r>
               <a:t>Estatísticas do Banco Central (BCB)</a:t>
             </a:r>
           </a:p>
           <a:p>
-            <a:pPr/>
-            <a:r>
-              <a:rPr/>
+            <a:r>
               <a:t>Comparações e insights</a:t>
             </a:r>
           </a:p>
           <a:p>
-            <a:pPr/>
-            <a:r>
-              <a:rPr/>
+            <a:r>
               <a:t>Conclusões e recomendações</a:t>
             </a:r>
           </a:p>
@@ -3586,7 +4110,7 @@
 </file>
 
 <file path=ppt/slides/slide3.xml><?xml version="1.0" encoding="utf-8"?>
-<p:sld xmlns:a="http://schemas.openxmlformats.org/drawingml/2006/main" xmlns:p="http://schemas.openxmlformats.org/presentationml/2006/main" xmlns:r="http://schemas.openxmlformats.org/officeDocument/2006/relationships">
+<p:sld xmlns:a="http://schemas.openxmlformats.org/drawingml/2006/main" xmlns:r="http://schemas.openxmlformats.org/officeDocument/2006/relationships" xmlns:p="http://schemas.openxmlformats.org/presentationml/2006/main">
   <p:cSld>
     <p:spTree>
       <p:nvGrpSpPr>
@@ -3594,7 +4118,14 @@
         <p:cNvGrpSpPr/>
         <p:nvPr/>
       </p:nvGrpSpPr>
-      <p:grpSpPr/>
+      <p:grpSpPr>
+        <a:xfrm>
+          <a:off x="0" y="0"/>
+          <a:ext cx="0" cy="0"/>
+          <a:chOff x="0" y="0"/>
+          <a:chExt cx="0" cy="0"/>
+        </a:xfrm>
+      </p:grpSpPr>
       <p:sp>
         <p:nvSpPr>
           <p:cNvPr id="2" name="Title 1"/>
@@ -3611,7 +4142,6 @@
           <a:lstStyle/>
           <a:p>
             <a:r>
-              <a:rPr/>
               <a:t>Desafio e Objetivos</a:t>
             </a:r>
           </a:p>
@@ -3627,21 +4157,314 @@
             <p:ph idx="1"/>
           </p:nvPr>
         </p:nvSpPr>
-        <p:spPr/>
-        <p:txBody>
-          <a:bodyPr/>
+        <p:spPr>
+          <a:xfrm>
+            <a:off x="313764" y="1573306"/>
+            <a:ext cx="8229600" cy="4525963"/>
+          </a:xfrm>
+        </p:spPr>
+        <p:txBody>
+          <a:bodyPr>
+            <a:normAutofit fontScale="85000" lnSpcReduction="10000"/>
+          </a:bodyPr>
           <a:lstStyle/>
           <a:p>
             <a:r>
-              <a:rPr/>
-              <a:t>O desafio consiste em desenvolver um pipeline automatizado para extrair e estruturar as regras de tarifas de intercâmbio a partir de manuais das bandeiras Visa e Mastercard, permitindo comparar taxas por tipo de cartão, segmento e modalidade de transação.</a:t>
-            </a:r>
-          </a:p>
-          <a:p/>
-          <a:p>
-            <a:r>
-              <a:rPr/>
-              <a:t>Além disso, é necessário compilar estatísticas do Banco Central (BCB) sobre pagamentos de varejo no Brasil para contextualizar o mercado e identificar tendências de uso de instrumentos de pagamento.</a:t>
+              <a:rPr dirty="0"/>
+              <a:t>O </a:t>
+            </a:r>
+            <a:r>
+              <a:rPr dirty="0" err="1"/>
+              <a:t>desafio</a:t>
+            </a:r>
+            <a:r>
+              <a:rPr dirty="0"/>
+              <a:t> </a:t>
+            </a:r>
+            <a:r>
+              <a:rPr dirty="0" err="1"/>
+              <a:t>consiste</a:t>
+            </a:r>
+            <a:r>
+              <a:rPr dirty="0"/>
+              <a:t> </a:t>
+            </a:r>
+            <a:r>
+              <a:rPr dirty="0" err="1"/>
+              <a:t>em</a:t>
+            </a:r>
+            <a:r>
+              <a:rPr dirty="0"/>
+              <a:t> </a:t>
+            </a:r>
+            <a:r>
+              <a:rPr dirty="0" err="1"/>
+              <a:t>desenvolver</a:t>
+            </a:r>
+            <a:r>
+              <a:rPr dirty="0"/>
+              <a:t> um pipeline </a:t>
+            </a:r>
+            <a:r>
+              <a:rPr dirty="0" err="1"/>
+              <a:t>automatizado</a:t>
+            </a:r>
+            <a:r>
+              <a:rPr dirty="0"/>
+              <a:t> para </a:t>
+            </a:r>
+            <a:r>
+              <a:rPr dirty="0" err="1"/>
+              <a:t>extrair</a:t>
+            </a:r>
+            <a:r>
+              <a:rPr dirty="0"/>
+              <a:t> e </a:t>
+            </a:r>
+            <a:r>
+              <a:rPr dirty="0" err="1"/>
+              <a:t>estruturar</a:t>
+            </a:r>
+            <a:r>
+              <a:rPr dirty="0"/>
+              <a:t> as </a:t>
+            </a:r>
+            <a:r>
+              <a:rPr dirty="0" err="1"/>
+              <a:t>regras</a:t>
+            </a:r>
+            <a:r>
+              <a:rPr dirty="0"/>
+              <a:t> de </a:t>
+            </a:r>
+            <a:r>
+              <a:rPr dirty="0" err="1"/>
+              <a:t>tarifas</a:t>
+            </a:r>
+            <a:r>
+              <a:rPr dirty="0"/>
+              <a:t> de </a:t>
+            </a:r>
+            <a:r>
+              <a:rPr dirty="0" err="1"/>
+              <a:t>intercâmbio</a:t>
+            </a:r>
+            <a:r>
+              <a:rPr dirty="0"/>
+              <a:t> a </a:t>
+            </a:r>
+            <a:r>
+              <a:rPr dirty="0" err="1"/>
+              <a:t>partir</a:t>
+            </a:r>
+            <a:r>
+              <a:rPr dirty="0"/>
+              <a:t> de </a:t>
+            </a:r>
+            <a:r>
+              <a:rPr dirty="0" err="1"/>
+              <a:t>manuais</a:t>
+            </a:r>
+            <a:r>
+              <a:rPr dirty="0"/>
+              <a:t> das </a:t>
+            </a:r>
+            <a:r>
+              <a:rPr dirty="0" err="1"/>
+              <a:t>bandeiras</a:t>
+            </a:r>
+            <a:r>
+              <a:rPr dirty="0"/>
+              <a:t> Visa e Mastercard, </a:t>
+            </a:r>
+            <a:r>
+              <a:rPr dirty="0" err="1"/>
+              <a:t>permitindo</a:t>
+            </a:r>
+            <a:r>
+              <a:rPr dirty="0"/>
+              <a:t> </a:t>
+            </a:r>
+            <a:r>
+              <a:rPr dirty="0" err="1"/>
+              <a:t>comparar</a:t>
+            </a:r>
+            <a:r>
+              <a:rPr dirty="0"/>
+              <a:t> </a:t>
+            </a:r>
+            <a:r>
+              <a:rPr dirty="0" err="1"/>
+              <a:t>taxas</a:t>
+            </a:r>
+            <a:r>
+              <a:rPr dirty="0"/>
+              <a:t> por </a:t>
+            </a:r>
+            <a:r>
+              <a:rPr dirty="0" err="1"/>
+              <a:t>tipo</a:t>
+            </a:r>
+            <a:r>
+              <a:rPr dirty="0"/>
+              <a:t> de </a:t>
+            </a:r>
+            <a:r>
+              <a:rPr dirty="0" err="1"/>
+              <a:t>cartão</a:t>
+            </a:r>
+            <a:r>
+              <a:rPr dirty="0"/>
+              <a:t>, </a:t>
+            </a:r>
+            <a:r>
+              <a:rPr dirty="0" err="1"/>
+              <a:t>segmento</a:t>
+            </a:r>
+            <a:r>
+              <a:rPr dirty="0"/>
+              <a:t> e </a:t>
+            </a:r>
+            <a:r>
+              <a:rPr dirty="0" err="1"/>
+              <a:t>modalidade</a:t>
+            </a:r>
+            <a:r>
+              <a:rPr dirty="0"/>
+              <a:t> de </a:t>
+            </a:r>
+            <a:r>
+              <a:rPr dirty="0" err="1"/>
+              <a:t>transação</a:t>
+            </a:r>
+            <a:r>
+              <a:rPr dirty="0"/>
+              <a:t>.</a:t>
+            </a:r>
+          </a:p>
+          <a:p>
+            <a:endParaRPr dirty="0"/>
+          </a:p>
+          <a:p>
+            <a:r>
+              <a:rPr dirty="0" err="1"/>
+              <a:t>Além</a:t>
+            </a:r>
+            <a:r>
+              <a:rPr dirty="0"/>
+              <a:t> </a:t>
+            </a:r>
+            <a:r>
+              <a:rPr dirty="0" err="1"/>
+              <a:t>disso</a:t>
+            </a:r>
+            <a:r>
+              <a:rPr dirty="0"/>
+              <a:t>, é </a:t>
+            </a:r>
+            <a:r>
+              <a:rPr dirty="0" err="1"/>
+              <a:t>necessário</a:t>
+            </a:r>
+            <a:r>
+              <a:rPr dirty="0"/>
+              <a:t> </a:t>
+            </a:r>
+            <a:r>
+              <a:rPr dirty="0" err="1"/>
+              <a:t>compilar</a:t>
+            </a:r>
+            <a:r>
+              <a:rPr dirty="0"/>
+              <a:t> </a:t>
+            </a:r>
+            <a:r>
+              <a:rPr dirty="0" err="1"/>
+              <a:t>estatísticas</a:t>
+            </a:r>
+            <a:r>
+              <a:rPr dirty="0"/>
+              <a:t> do Banco Central (BCB) </a:t>
+            </a:r>
+            <a:r>
+              <a:rPr dirty="0" err="1"/>
+              <a:t>sobre</a:t>
+            </a:r>
+            <a:r>
+              <a:rPr dirty="0"/>
+              <a:t> </a:t>
+            </a:r>
+            <a:r>
+              <a:rPr dirty="0" err="1"/>
+              <a:t>pagamentos</a:t>
+            </a:r>
+            <a:r>
+              <a:rPr dirty="0"/>
+              <a:t> de </a:t>
+            </a:r>
+            <a:r>
+              <a:rPr dirty="0" err="1"/>
+              <a:t>varejo</a:t>
+            </a:r>
+            <a:r>
+              <a:rPr dirty="0"/>
+              <a:t> no </a:t>
+            </a:r>
+            <a:r>
+              <a:rPr dirty="0" err="1"/>
+              <a:t>Brasil</a:t>
+            </a:r>
+            <a:r>
+              <a:rPr dirty="0"/>
+              <a:t> para </a:t>
+            </a:r>
+            <a:r>
+              <a:rPr dirty="0" err="1"/>
+              <a:t>contextualizar</a:t>
+            </a:r>
+            <a:r>
+              <a:rPr dirty="0"/>
+              <a:t> o mercado e </a:t>
+            </a:r>
+            <a:r>
+              <a:rPr dirty="0" err="1"/>
+              <a:t>identificar</a:t>
+            </a:r>
+            <a:r>
+              <a:rPr dirty="0"/>
+              <a:t> </a:t>
+            </a:r>
+            <a:r>
+              <a:rPr dirty="0" err="1"/>
+              <a:t>tendências</a:t>
+            </a:r>
+            <a:r>
+              <a:rPr dirty="0"/>
+              <a:t> de </a:t>
+            </a:r>
+            <a:r>
+              <a:rPr dirty="0" err="1"/>
+              <a:t>uso</a:t>
+            </a:r>
+            <a:r>
+              <a:rPr dirty="0"/>
+              <a:t> de </a:t>
+            </a:r>
+            <a:r>
+              <a:rPr dirty="0" err="1"/>
+              <a:t>instrumentos</a:t>
+            </a:r>
+            <a:r>
+              <a:rPr dirty="0"/>
+              <a:t> de </a:t>
+            </a:r>
+            <a:r>
+              <a:rPr dirty="0" err="1"/>
+              <a:t>pagamento</a:t>
+            </a:r>
+            <a:r>
+              <a:rPr dirty="0"/>
+              <a:t>.</a:t>
             </a:r>
           </a:p>
         </p:txBody>
@@ -3655,7 +4478,7 @@
 </file>
 
 <file path=ppt/slides/slide4.xml><?xml version="1.0" encoding="utf-8"?>
-<p:sld xmlns:a="http://schemas.openxmlformats.org/drawingml/2006/main" xmlns:p="http://schemas.openxmlformats.org/presentationml/2006/main" xmlns:r="http://schemas.openxmlformats.org/officeDocument/2006/relationships">
+<p:sld xmlns:a="http://schemas.openxmlformats.org/drawingml/2006/main" xmlns:r="http://schemas.openxmlformats.org/officeDocument/2006/relationships" xmlns:p="http://schemas.openxmlformats.org/presentationml/2006/main">
   <p:cSld>
     <p:spTree>
       <p:nvGrpSpPr>
@@ -3663,7 +4486,14 @@
         <p:cNvGrpSpPr/>
         <p:nvPr/>
       </p:nvGrpSpPr>
-      <p:grpSpPr/>
+      <p:grpSpPr>
+        <a:xfrm>
+          <a:off x="0" y="0"/>
+          <a:ext cx="0" cy="0"/>
+          <a:chOff x="0" y="0"/>
+          <a:chExt cx="0" cy="0"/>
+        </a:xfrm>
+      </p:grpSpPr>
       <p:sp>
         <p:nvSpPr>
           <p:cNvPr id="2" name="Title 1"/>
@@ -3680,8 +4510,20 @@
           <a:lstStyle/>
           <a:p>
             <a:r>
-              <a:rPr/>
-              <a:t>Metodologia de Extração de Dados</a:t>
+              <a:rPr dirty="0" err="1"/>
+              <a:t>Metodologia</a:t>
+            </a:r>
+            <a:r>
+              <a:rPr dirty="0"/>
+              <a:t> de </a:t>
+            </a:r>
+            <a:r>
+              <a:rPr dirty="0" err="1"/>
+              <a:t>Extração</a:t>
+            </a:r>
+            <a:r>
+              <a:rPr dirty="0"/>
+              <a:t> de Dados</a:t>
             </a:r>
           </a:p>
         </p:txBody>
@@ -3696,44 +4538,308 @@
             <p:ph idx="1"/>
           </p:nvPr>
         </p:nvSpPr>
-        <p:spPr/>
-        <p:txBody>
-          <a:bodyPr/>
+        <p:spPr>
+          <a:xfrm>
+            <a:off x="457200" y="841656"/>
+            <a:ext cx="8229600" cy="4525963"/>
+          </a:xfrm>
+        </p:spPr>
+        <p:txBody>
+          <a:bodyPr>
+            <a:normAutofit fontScale="85000" lnSpcReduction="20000"/>
+          </a:bodyPr>
           <a:lstStyle/>
-          <a:p/>
-          <a:p>
-            <a:pPr/>
-            <a:r>
-              <a:rPr/>
-              <a:t>Pesquisa de documentos oficiais e tabelas nas páginas das bandeiras (Visa e Mastercard).</a:t>
-            </a:r>
-          </a:p>
-          <a:p>
-            <a:pPr/>
-            <a:r>
-              <a:rPr/>
-              <a:t>Extração manual e via OCR dos dados em PDFs e imagens (tabelas em PNG no site da Mastercard).</a:t>
-            </a:r>
-          </a:p>
-          <a:p>
-            <a:pPr/>
-            <a:r>
-              <a:rPr/>
-              <a:t>Estruturação dos dados em planilhas: identificação de categorias (tipo de cartão, segmento, ajustes).</a:t>
-            </a:r>
-          </a:p>
-          <a:p>
-            <a:pPr/>
-            <a:r>
-              <a:rPr/>
-              <a:t>Incorporação de estatísticas do Banco Central sobre volume de transações, participação de mercado e limites regulatórios de tarifa de intercâmbio.</a:t>
-            </a:r>
-          </a:p>
-          <a:p>
-            <a:pPr/>
-            <a:r>
-              <a:rPr/>
-              <a:t>Organização em diferentes sheets (Visa, Mastercard, BCB) para facilitar análises comparativas.</a:t>
+          <a:p>
+            <a:endParaRPr dirty="0"/>
+          </a:p>
+          <a:p>
+            <a:r>
+              <a:rPr dirty="0" err="1"/>
+              <a:t>Pesquisa</a:t>
+            </a:r>
+            <a:r>
+              <a:rPr dirty="0"/>
+              <a:t> de </a:t>
+            </a:r>
+            <a:r>
+              <a:rPr dirty="0" err="1"/>
+              <a:t>documentos</a:t>
+            </a:r>
+            <a:r>
+              <a:rPr dirty="0"/>
+              <a:t> </a:t>
+            </a:r>
+            <a:r>
+              <a:rPr dirty="0" err="1"/>
+              <a:t>oficiais</a:t>
+            </a:r>
+            <a:r>
+              <a:rPr dirty="0"/>
+              <a:t> e </a:t>
+            </a:r>
+            <a:r>
+              <a:rPr dirty="0" err="1"/>
+              <a:t>tabelas</a:t>
+            </a:r>
+            <a:r>
+              <a:rPr dirty="0"/>
+              <a:t> </a:t>
+            </a:r>
+            <a:r>
+              <a:rPr dirty="0" err="1"/>
+              <a:t>nas</a:t>
+            </a:r>
+            <a:r>
+              <a:rPr dirty="0"/>
+              <a:t> </a:t>
+            </a:r>
+            <a:r>
+              <a:rPr dirty="0" err="1"/>
+              <a:t>páginas</a:t>
+            </a:r>
+            <a:r>
+              <a:rPr dirty="0"/>
+              <a:t> das </a:t>
+            </a:r>
+            <a:r>
+              <a:rPr dirty="0" err="1"/>
+              <a:t>bandeiras</a:t>
+            </a:r>
+            <a:r>
+              <a:rPr dirty="0"/>
+              <a:t> (Visa e Mastercard).</a:t>
+            </a:r>
+          </a:p>
+          <a:p>
+            <a:r>
+              <a:rPr dirty="0" err="1"/>
+              <a:t>Extração</a:t>
+            </a:r>
+            <a:r>
+              <a:rPr dirty="0"/>
+              <a:t> manual e via OCR dos dados </a:t>
+            </a:r>
+            <a:r>
+              <a:rPr dirty="0" err="1"/>
+              <a:t>em</a:t>
+            </a:r>
+            <a:r>
+              <a:rPr dirty="0"/>
+              <a:t> PDFs e imagens (</a:t>
+            </a:r>
+            <a:r>
+              <a:rPr dirty="0" err="1"/>
+              <a:t>tabelas</a:t>
+            </a:r>
+            <a:r>
+              <a:rPr dirty="0"/>
+              <a:t> </a:t>
+            </a:r>
+            <a:r>
+              <a:rPr dirty="0" err="1"/>
+              <a:t>em</a:t>
+            </a:r>
+            <a:r>
+              <a:rPr dirty="0"/>
+              <a:t> PNG no site da Mastercard).</a:t>
+            </a:r>
+          </a:p>
+          <a:p>
+            <a:r>
+              <a:rPr dirty="0" err="1"/>
+              <a:t>Estruturação</a:t>
+            </a:r>
+            <a:r>
+              <a:rPr dirty="0"/>
+              <a:t> dos dados </a:t>
+            </a:r>
+            <a:r>
+              <a:rPr dirty="0" err="1"/>
+              <a:t>em</a:t>
+            </a:r>
+            <a:r>
+              <a:rPr dirty="0"/>
+              <a:t> </a:t>
+            </a:r>
+            <a:r>
+              <a:rPr dirty="0" err="1"/>
+              <a:t>planilhas</a:t>
+            </a:r>
+            <a:r>
+              <a:rPr dirty="0"/>
+              <a:t>: </a:t>
+            </a:r>
+            <a:r>
+              <a:rPr dirty="0" err="1"/>
+              <a:t>identificação</a:t>
+            </a:r>
+            <a:r>
+              <a:rPr dirty="0"/>
+              <a:t> de </a:t>
+            </a:r>
+            <a:r>
+              <a:rPr dirty="0" err="1"/>
+              <a:t>categorias</a:t>
+            </a:r>
+            <a:r>
+              <a:rPr dirty="0"/>
+              <a:t> (</a:t>
+            </a:r>
+            <a:r>
+              <a:rPr dirty="0" err="1"/>
+              <a:t>tipo</a:t>
+            </a:r>
+            <a:r>
+              <a:rPr dirty="0"/>
+              <a:t> de </a:t>
+            </a:r>
+            <a:r>
+              <a:rPr dirty="0" err="1"/>
+              <a:t>cartão</a:t>
+            </a:r>
+            <a:r>
+              <a:rPr dirty="0"/>
+              <a:t>, </a:t>
+            </a:r>
+            <a:r>
+              <a:rPr dirty="0" err="1"/>
+              <a:t>segmento</a:t>
+            </a:r>
+            <a:r>
+              <a:rPr dirty="0"/>
+              <a:t>, </a:t>
+            </a:r>
+            <a:r>
+              <a:rPr dirty="0" err="1"/>
+              <a:t>ajustes</a:t>
+            </a:r>
+            <a:r>
+              <a:rPr dirty="0"/>
+              <a:t>).</a:t>
+            </a:r>
+          </a:p>
+          <a:p>
+            <a:r>
+              <a:rPr dirty="0" err="1"/>
+              <a:t>Incorporação</a:t>
+            </a:r>
+            <a:r>
+              <a:rPr dirty="0"/>
+              <a:t> de </a:t>
+            </a:r>
+            <a:r>
+              <a:rPr dirty="0" err="1"/>
+              <a:t>estatísticas</a:t>
+            </a:r>
+            <a:r>
+              <a:rPr dirty="0"/>
+              <a:t> do Banco Central </a:t>
+            </a:r>
+            <a:r>
+              <a:rPr dirty="0" err="1"/>
+              <a:t>sobre</a:t>
+            </a:r>
+            <a:r>
+              <a:rPr dirty="0"/>
+              <a:t> volume de </a:t>
+            </a:r>
+            <a:r>
+              <a:rPr dirty="0" err="1"/>
+              <a:t>transações</a:t>
+            </a:r>
+            <a:r>
+              <a:rPr dirty="0"/>
+              <a:t>, </a:t>
+            </a:r>
+            <a:r>
+              <a:rPr dirty="0" err="1"/>
+              <a:t>participação</a:t>
+            </a:r>
+            <a:r>
+              <a:rPr dirty="0"/>
+              <a:t> de mercado e </a:t>
+            </a:r>
+            <a:r>
+              <a:rPr dirty="0" err="1"/>
+              <a:t>limites</a:t>
+            </a:r>
+            <a:r>
+              <a:rPr dirty="0"/>
+              <a:t> </a:t>
+            </a:r>
+            <a:r>
+              <a:rPr dirty="0" err="1"/>
+              <a:t>regulatórios</a:t>
+            </a:r>
+            <a:r>
+              <a:rPr dirty="0"/>
+              <a:t> de </a:t>
+            </a:r>
+            <a:r>
+              <a:rPr dirty="0" err="1"/>
+              <a:t>tarifa</a:t>
+            </a:r>
+            <a:r>
+              <a:rPr dirty="0"/>
+              <a:t> de </a:t>
+            </a:r>
+            <a:r>
+              <a:rPr dirty="0" err="1"/>
+              <a:t>intercâmbio</a:t>
+            </a:r>
+            <a:r>
+              <a:rPr dirty="0"/>
+              <a:t>.</a:t>
+            </a:r>
+          </a:p>
+          <a:p>
+            <a:r>
+              <a:rPr dirty="0" err="1"/>
+              <a:t>Organização</a:t>
+            </a:r>
+            <a:r>
+              <a:rPr dirty="0"/>
+              <a:t> </a:t>
+            </a:r>
+            <a:r>
+              <a:rPr dirty="0" err="1"/>
+              <a:t>em</a:t>
+            </a:r>
+            <a:r>
+              <a:rPr dirty="0"/>
+              <a:t> </a:t>
+            </a:r>
+            <a:r>
+              <a:rPr dirty="0" err="1"/>
+              <a:t>diferentes</a:t>
+            </a:r>
+            <a:r>
+              <a:rPr dirty="0"/>
+              <a:t> sheets (Visa, Mastercard, BCB) para </a:t>
+            </a:r>
+            <a:r>
+              <a:rPr dirty="0" err="1"/>
+              <a:t>facilitar</a:t>
+            </a:r>
+            <a:r>
+              <a:rPr dirty="0"/>
+              <a:t> </a:t>
+            </a:r>
+            <a:r>
+              <a:rPr dirty="0" err="1"/>
+              <a:t>análises</a:t>
+            </a:r>
+            <a:r>
+              <a:rPr dirty="0"/>
+              <a:t> </a:t>
+            </a:r>
+            <a:r>
+              <a:rPr dirty="0" err="1"/>
+              <a:t>comparativas</a:t>
+            </a:r>
+            <a:r>
+              <a:rPr dirty="0"/>
+              <a:t>.</a:t>
             </a:r>
           </a:p>
         </p:txBody>
@@ -3747,7 +4853,7 @@
 </file>
 
 <file path=ppt/slides/slide5.xml><?xml version="1.0" encoding="utf-8"?>
-<p:sld xmlns:a="http://schemas.openxmlformats.org/drawingml/2006/main" xmlns:p="http://schemas.openxmlformats.org/presentationml/2006/main" xmlns:r="http://schemas.openxmlformats.org/officeDocument/2006/relationships">
+<p:sld xmlns:a="http://schemas.openxmlformats.org/drawingml/2006/main" xmlns:r="http://schemas.openxmlformats.org/officeDocument/2006/relationships" xmlns:p="http://schemas.openxmlformats.org/presentationml/2006/main">
   <p:cSld>
     <p:spTree>
       <p:nvGrpSpPr>
@@ -3755,7 +4861,14 @@
         <p:cNvGrpSpPr/>
         <p:nvPr/>
       </p:nvGrpSpPr>
-      <p:grpSpPr/>
+      <p:grpSpPr>
+        <a:xfrm>
+          <a:off x="0" y="0"/>
+          <a:ext cx="0" cy="0"/>
+          <a:chOff x="0" y="0"/>
+          <a:chExt cx="0" cy="0"/>
+        </a:xfrm>
+      </p:grpSpPr>
       <p:sp>
         <p:nvSpPr>
           <p:cNvPr id="2" name="Title 1"/>
@@ -3772,7 +4885,6 @@
           <a:lstStyle/>
           <a:p>
             <a:r>
-              <a:rPr/>
               <a:t>Tarifas de Intercâmbio – Visa (Brasil)</a:t>
             </a:r>
           </a:p>
@@ -3788,44 +4900,452 @@
             <p:ph idx="1"/>
           </p:nvPr>
         </p:nvSpPr>
-        <p:spPr/>
-        <p:txBody>
-          <a:bodyPr/>
+        <p:spPr>
+          <a:xfrm>
+            <a:off x="457200" y="1166018"/>
+            <a:ext cx="8229600" cy="4525963"/>
+          </a:xfrm>
+        </p:spPr>
+        <p:txBody>
+          <a:bodyPr>
+            <a:normAutofit fontScale="70000" lnSpcReduction="20000"/>
+          </a:bodyPr>
           <a:lstStyle/>
-          <a:p/>
-          <a:p>
-            <a:pPr/>
-            <a:r>
-              <a:rPr/>
-              <a:t>Crédito (consumidor): taxas base variam de 1,17% (Classic) a 1,83% (Infinite) com ajustes para pagamentos sem contato (+0,00%) e compras online ou não presenciais (+0,20%). Parcelamentos de 2–6 parcelas adicionam +0,65 p.p. e 7–21 parcelas +0,90 p.p. por transação.</a:t>
-            </a:r>
-          </a:p>
-          <a:p>
-            <a:pPr/>
-            <a:r>
-              <a:rPr/>
-              <a:t>Crédito (comercial): informações públicas limitadas; base aproximada de 1,65% a 1,80% dependendo do segmento.</a:t>
-            </a:r>
-          </a:p>
-          <a:p>
-            <a:pPr/>
-            <a:r>
-              <a:rPr/>
-              <a:t>Débito: taxa fixa de 0,50% em todas as transações, conforme regulamentação do BCB.</a:t>
-            </a:r>
-          </a:p>
-          <a:p>
-            <a:pPr/>
-            <a:r>
-              <a:rPr/>
-              <a:t>Pré‑pago: taxa fixa de 0,70% por transação (consumidor ou comercial).</a:t>
-            </a:r>
-          </a:p>
-          <a:p>
-            <a:pPr/>
-            <a:r>
-              <a:rPr/>
-              <a:t>Ajustes por segmento: alguns segmentos (supermercados, hotéis, viagens, etc.) podem ter reduções, mas as diretrizes públicas indicam variações menores.</a:t>
+          <a:p>
+            <a:endParaRPr dirty="0"/>
+          </a:p>
+          <a:p>
+            <a:r>
+              <a:rPr dirty="0" err="1"/>
+              <a:t>Crédito</a:t>
+            </a:r>
+            <a:r>
+              <a:rPr dirty="0"/>
+              <a:t> (</a:t>
+            </a:r>
+            <a:r>
+              <a:rPr dirty="0" err="1"/>
+              <a:t>consumidor</a:t>
+            </a:r>
+            <a:r>
+              <a:rPr dirty="0"/>
+              <a:t>): </a:t>
+            </a:r>
+            <a:r>
+              <a:rPr dirty="0" err="1"/>
+              <a:t>taxas</a:t>
+            </a:r>
+            <a:r>
+              <a:rPr dirty="0"/>
+              <a:t> base </a:t>
+            </a:r>
+            <a:r>
+              <a:rPr dirty="0" err="1"/>
+              <a:t>variam</a:t>
+            </a:r>
+            <a:r>
+              <a:rPr dirty="0"/>
+              <a:t> de 1,17% (Classic) a 1,83% (Infinite) com </a:t>
+            </a:r>
+            <a:r>
+              <a:rPr dirty="0" err="1"/>
+              <a:t>ajustes</a:t>
+            </a:r>
+            <a:r>
+              <a:rPr dirty="0"/>
+              <a:t> para </a:t>
+            </a:r>
+            <a:r>
+              <a:rPr dirty="0" err="1"/>
+              <a:t>pagamentos</a:t>
+            </a:r>
+            <a:r>
+              <a:rPr dirty="0"/>
+              <a:t> </a:t>
+            </a:r>
+            <a:r>
+              <a:rPr dirty="0" err="1"/>
+              <a:t>sem</a:t>
+            </a:r>
+            <a:r>
+              <a:rPr dirty="0"/>
+              <a:t> </a:t>
+            </a:r>
+            <a:r>
+              <a:rPr dirty="0" err="1"/>
+              <a:t>contato</a:t>
+            </a:r>
+            <a:r>
+              <a:rPr dirty="0"/>
+              <a:t> (+0,00%) e </a:t>
+            </a:r>
+            <a:r>
+              <a:rPr dirty="0" err="1"/>
+              <a:t>compras</a:t>
+            </a:r>
+            <a:r>
+              <a:rPr dirty="0"/>
+              <a:t> online </a:t>
+            </a:r>
+            <a:r>
+              <a:rPr dirty="0" err="1"/>
+              <a:t>ou</a:t>
+            </a:r>
+            <a:r>
+              <a:rPr dirty="0"/>
+              <a:t> </a:t>
+            </a:r>
+            <a:r>
+              <a:rPr dirty="0" err="1"/>
+              <a:t>não</a:t>
+            </a:r>
+            <a:r>
+              <a:rPr dirty="0"/>
+              <a:t> </a:t>
+            </a:r>
+            <a:r>
+              <a:rPr dirty="0" err="1"/>
+              <a:t>presenciais</a:t>
+            </a:r>
+            <a:r>
+              <a:rPr dirty="0"/>
+              <a:t> (+0,20%). </a:t>
+            </a:r>
+            <a:r>
+              <a:rPr dirty="0" err="1"/>
+              <a:t>Parcelamentos</a:t>
+            </a:r>
+            <a:r>
+              <a:rPr dirty="0"/>
+              <a:t> de 2–6 </a:t>
+            </a:r>
+            <a:r>
+              <a:rPr dirty="0" err="1"/>
+              <a:t>parcelas</a:t>
+            </a:r>
+            <a:r>
+              <a:rPr dirty="0"/>
+              <a:t> </a:t>
+            </a:r>
+            <a:r>
+              <a:rPr dirty="0" err="1"/>
+              <a:t>adicionam</a:t>
+            </a:r>
+            <a:r>
+              <a:rPr dirty="0"/>
+              <a:t> +0,65 p.p. e 7–21 </a:t>
+            </a:r>
+            <a:r>
+              <a:rPr dirty="0" err="1"/>
+              <a:t>parcelas</a:t>
+            </a:r>
+            <a:r>
+              <a:rPr dirty="0"/>
+              <a:t> +0,90 p.p. por </a:t>
+            </a:r>
+            <a:r>
+              <a:rPr dirty="0" err="1"/>
+              <a:t>transação</a:t>
+            </a:r>
+            <a:r>
+              <a:rPr dirty="0"/>
+              <a:t>.</a:t>
+            </a:r>
+          </a:p>
+          <a:p>
+            <a:r>
+              <a:rPr dirty="0" err="1"/>
+              <a:t>Crédito</a:t>
+            </a:r>
+            <a:r>
+              <a:rPr dirty="0"/>
+              <a:t> (</a:t>
+            </a:r>
+            <a:r>
+              <a:rPr dirty="0" err="1"/>
+              <a:t>comercial</a:t>
+            </a:r>
+            <a:r>
+              <a:rPr dirty="0"/>
+              <a:t>): </a:t>
+            </a:r>
+            <a:r>
+              <a:rPr dirty="0" err="1"/>
+              <a:t>informações</a:t>
+            </a:r>
+            <a:r>
+              <a:rPr dirty="0"/>
+              <a:t> </a:t>
+            </a:r>
+            <a:r>
+              <a:rPr dirty="0" err="1"/>
+              <a:t>públicas</a:t>
+            </a:r>
+            <a:r>
+              <a:rPr dirty="0"/>
+              <a:t> </a:t>
+            </a:r>
+            <a:r>
+              <a:rPr dirty="0" err="1"/>
+              <a:t>limitadas</a:t>
+            </a:r>
+            <a:r>
+              <a:rPr dirty="0"/>
+              <a:t>; base </a:t>
+            </a:r>
+            <a:r>
+              <a:rPr dirty="0" err="1"/>
+              <a:t>aproximada</a:t>
+            </a:r>
+            <a:r>
+              <a:rPr dirty="0"/>
+              <a:t> de 1,65% a 1,80% </a:t>
+            </a:r>
+            <a:r>
+              <a:rPr dirty="0" err="1"/>
+              <a:t>dependendo</a:t>
+            </a:r>
+            <a:r>
+              <a:rPr dirty="0"/>
+              <a:t> do </a:t>
+            </a:r>
+            <a:r>
+              <a:rPr dirty="0" err="1"/>
+              <a:t>segmento</a:t>
+            </a:r>
+            <a:r>
+              <a:rPr dirty="0"/>
+              <a:t>.</a:t>
+            </a:r>
+          </a:p>
+          <a:p>
+            <a:r>
+              <a:rPr dirty="0" err="1"/>
+              <a:t>Débito</a:t>
+            </a:r>
+            <a:r>
+              <a:rPr dirty="0"/>
+              <a:t>: taxa </a:t>
+            </a:r>
+            <a:r>
+              <a:rPr dirty="0" err="1"/>
+              <a:t>fixa</a:t>
+            </a:r>
+            <a:r>
+              <a:rPr dirty="0"/>
+              <a:t> de 0,50% </a:t>
+            </a:r>
+            <a:r>
+              <a:rPr dirty="0" err="1"/>
+              <a:t>em</a:t>
+            </a:r>
+            <a:r>
+              <a:rPr dirty="0"/>
+              <a:t> </a:t>
+            </a:r>
+            <a:r>
+              <a:rPr dirty="0" err="1"/>
+              <a:t>todas</a:t>
+            </a:r>
+            <a:r>
+              <a:rPr dirty="0"/>
+              <a:t> as </a:t>
+            </a:r>
+            <a:r>
+              <a:rPr dirty="0" err="1"/>
+              <a:t>transações</a:t>
+            </a:r>
+            <a:r>
+              <a:rPr dirty="0"/>
+              <a:t>, </a:t>
+            </a:r>
+            <a:r>
+              <a:rPr dirty="0" err="1"/>
+              <a:t>conforme</a:t>
+            </a:r>
+            <a:r>
+              <a:rPr dirty="0"/>
+              <a:t> </a:t>
+            </a:r>
+            <a:r>
+              <a:rPr dirty="0" err="1"/>
+              <a:t>regulamentação</a:t>
+            </a:r>
+            <a:r>
+              <a:rPr dirty="0"/>
+              <a:t> do BCB.</a:t>
+            </a:r>
+          </a:p>
+          <a:p>
+            <a:r>
+              <a:rPr dirty="0" err="1"/>
+              <a:t>Pré‑pago</a:t>
+            </a:r>
+            <a:r>
+              <a:rPr dirty="0"/>
+              <a:t>: taxa </a:t>
+            </a:r>
+            <a:r>
+              <a:rPr dirty="0" err="1"/>
+              <a:t>fixa</a:t>
+            </a:r>
+            <a:r>
+              <a:rPr dirty="0"/>
+              <a:t> de 0,70% por </a:t>
+            </a:r>
+            <a:r>
+              <a:rPr dirty="0" err="1"/>
+              <a:t>transação</a:t>
+            </a:r>
+            <a:r>
+              <a:rPr dirty="0"/>
+              <a:t> (</a:t>
+            </a:r>
+            <a:r>
+              <a:rPr dirty="0" err="1"/>
+              <a:t>consumidor</a:t>
+            </a:r>
+            <a:r>
+              <a:rPr dirty="0"/>
+              <a:t> </a:t>
+            </a:r>
+            <a:r>
+              <a:rPr dirty="0" err="1"/>
+              <a:t>ou</a:t>
+            </a:r>
+            <a:r>
+              <a:rPr dirty="0"/>
+              <a:t> </a:t>
+            </a:r>
+            <a:r>
+              <a:rPr dirty="0" err="1"/>
+              <a:t>comercial</a:t>
+            </a:r>
+            <a:r>
+              <a:rPr dirty="0"/>
+              <a:t>).</a:t>
+            </a:r>
+          </a:p>
+          <a:p>
+            <a:r>
+              <a:rPr dirty="0" err="1"/>
+              <a:t>Ajustes</a:t>
+            </a:r>
+            <a:r>
+              <a:rPr dirty="0"/>
+              <a:t> por </a:t>
+            </a:r>
+            <a:r>
+              <a:rPr dirty="0" err="1"/>
+              <a:t>segmento</a:t>
+            </a:r>
+            <a:r>
+              <a:rPr dirty="0"/>
+              <a:t>: </a:t>
+            </a:r>
+            <a:r>
+              <a:rPr dirty="0" err="1"/>
+              <a:t>alguns</a:t>
+            </a:r>
+            <a:r>
+              <a:rPr dirty="0"/>
+              <a:t> </a:t>
+            </a:r>
+            <a:r>
+              <a:rPr dirty="0" err="1"/>
+              <a:t>segmentos</a:t>
+            </a:r>
+            <a:r>
+              <a:rPr dirty="0"/>
+              <a:t> (</a:t>
+            </a:r>
+            <a:r>
+              <a:rPr dirty="0" err="1"/>
+              <a:t>supermercados</a:t>
+            </a:r>
+            <a:r>
+              <a:rPr dirty="0"/>
+              <a:t>, </a:t>
+            </a:r>
+            <a:r>
+              <a:rPr dirty="0" err="1"/>
+              <a:t>hotéis</a:t>
+            </a:r>
+            <a:r>
+              <a:rPr dirty="0"/>
+              <a:t>, </a:t>
+            </a:r>
+            <a:r>
+              <a:rPr dirty="0" err="1"/>
+              <a:t>viagens</a:t>
+            </a:r>
+            <a:r>
+              <a:rPr dirty="0"/>
+              <a:t>, etc.) </a:t>
+            </a:r>
+            <a:r>
+              <a:rPr dirty="0" err="1"/>
+              <a:t>podem</a:t>
+            </a:r>
+            <a:r>
+              <a:rPr dirty="0"/>
+              <a:t> </a:t>
+            </a:r>
+            <a:r>
+              <a:rPr dirty="0" err="1"/>
+              <a:t>ter</a:t>
+            </a:r>
+            <a:r>
+              <a:rPr dirty="0"/>
+              <a:t> </a:t>
+            </a:r>
+            <a:r>
+              <a:rPr dirty="0" err="1"/>
+              <a:t>reduções</a:t>
+            </a:r>
+            <a:r>
+              <a:rPr dirty="0"/>
+              <a:t>, mas as </a:t>
+            </a:r>
+            <a:r>
+              <a:rPr dirty="0" err="1"/>
+              <a:t>diretrizes</a:t>
+            </a:r>
+            <a:r>
+              <a:rPr dirty="0"/>
+              <a:t> </a:t>
+            </a:r>
+            <a:r>
+              <a:rPr dirty="0" err="1"/>
+              <a:t>públicas</a:t>
+            </a:r>
+            <a:r>
+              <a:rPr dirty="0"/>
+              <a:t> </a:t>
+            </a:r>
+            <a:r>
+              <a:rPr dirty="0" err="1"/>
+              <a:t>indicam</a:t>
+            </a:r>
+            <a:r>
+              <a:rPr dirty="0"/>
+              <a:t> </a:t>
+            </a:r>
+            <a:r>
+              <a:rPr dirty="0" err="1"/>
+              <a:t>variações</a:t>
+            </a:r>
+            <a:r>
+              <a:rPr dirty="0"/>
+              <a:t> </a:t>
+            </a:r>
+            <a:r>
+              <a:rPr dirty="0" err="1"/>
+              <a:t>menores</a:t>
+            </a:r>
+            <a:r>
+              <a:rPr dirty="0"/>
+              <a:t>.</a:t>
             </a:r>
           </a:p>
         </p:txBody>
@@ -3839,7 +5359,7 @@
 </file>
 
 <file path=ppt/slides/slide6.xml><?xml version="1.0" encoding="utf-8"?>
-<p:sld xmlns:a="http://schemas.openxmlformats.org/drawingml/2006/main" xmlns:p="http://schemas.openxmlformats.org/presentationml/2006/main" xmlns:r="http://schemas.openxmlformats.org/officeDocument/2006/relationships">
+<p:sld xmlns:a="http://schemas.openxmlformats.org/drawingml/2006/main" xmlns:r="http://schemas.openxmlformats.org/officeDocument/2006/relationships" xmlns:p="http://schemas.openxmlformats.org/presentationml/2006/main">
   <p:cSld>
     <p:spTree>
       <p:nvGrpSpPr>
@@ -3847,7 +5367,14 @@
         <p:cNvGrpSpPr/>
         <p:nvPr/>
       </p:nvGrpSpPr>
-      <p:grpSpPr/>
+      <p:grpSpPr>
+        <a:xfrm>
+          <a:off x="0" y="0"/>
+          <a:ext cx="0" cy="0"/>
+          <a:chOff x="0" y="0"/>
+          <a:chExt cx="0" cy="0"/>
+        </a:xfrm>
+      </p:grpSpPr>
       <p:sp>
         <p:nvSpPr>
           <p:cNvPr id="2" name="Title 1"/>
@@ -3864,7 +5391,6 @@
           <a:lstStyle/>
           <a:p>
             <a:r>
-              <a:rPr/>
               <a:t>Tarifas de Intercâmbio – Mastercard (Crédito Consumidor)</a:t>
             </a:r>
           </a:p>
@@ -3884,32 +5410,26 @@
         <p:txBody>
           <a:bodyPr/>
           <a:lstStyle/>
-          <a:p/>
-          <a:p>
-            <a:pPr/>
-            <a:r>
-              <a:rPr/>
+          <a:p>
+            <a:endParaRPr/>
+          </a:p>
+          <a:p>
+            <a:r>
               <a:t>Taxas base por categoria: Standard 1,10%, Gold 1,20%, Platinum 1,65%, Black 1,80% e World Legend 2,22%.</a:t>
             </a:r>
           </a:p>
           <a:p>
-            <a:pPr/>
-            <a:r>
-              <a:rPr/>
+            <a:r>
               <a:t>Segmentos: Supermercados (~0,95–1,40%), Despesas Gerais (0,50–0,80%), Outros (0,85–0,90%), Serviços governamentais (~1,20%), Transporte (0,65%), Viagens &amp; Entretenimento (0,85–1,70%), Atacadistas (0,65–0,85%), Loteria (0,50%).</a:t>
             </a:r>
           </a:p>
           <a:p>
-            <a:pPr/>
-            <a:r>
-              <a:rPr/>
+            <a:r>
               <a:t>Ajustes: pagamentos sem contato +0,05 p.p.; compras online ou não presenciais +0,20 p.p. (supermercados +0,10 p.p.).</a:t>
             </a:r>
           </a:p>
           <a:p>
-            <a:pPr/>
-            <a:r>
-              <a:rPr/>
+            <a:r>
               <a:t>Parcelamentos: 2–6 parcelas +0,65 p.p.; 7–21 parcelas +0,90 p.p. com teto de R$ 0,90 por transação.</a:t>
             </a:r>
           </a:p>
@@ -3924,7 +5444,7 @@
 </file>
 
 <file path=ppt/slides/slide7.xml><?xml version="1.0" encoding="utf-8"?>
-<p:sld xmlns:a="http://schemas.openxmlformats.org/drawingml/2006/main" xmlns:p="http://schemas.openxmlformats.org/presentationml/2006/main" xmlns:r="http://schemas.openxmlformats.org/officeDocument/2006/relationships">
+<p:sld xmlns:a="http://schemas.openxmlformats.org/drawingml/2006/main" xmlns:r="http://schemas.openxmlformats.org/officeDocument/2006/relationships" xmlns:p="http://schemas.openxmlformats.org/presentationml/2006/main">
   <p:cSld>
     <p:spTree>
       <p:nvGrpSpPr>
@@ -3932,7 +5452,14 @@
         <p:cNvGrpSpPr/>
         <p:nvPr/>
       </p:nvGrpSpPr>
-      <p:grpSpPr/>
+      <p:grpSpPr>
+        <a:xfrm>
+          <a:off x="0" y="0"/>
+          <a:ext cx="0" cy="0"/>
+          <a:chOff x="0" y="0"/>
+          <a:chExt cx="0" cy="0"/>
+        </a:xfrm>
+      </p:grpSpPr>
       <p:sp>
         <p:nvSpPr>
           <p:cNvPr id="2" name="Title 1"/>
@@ -3949,7 +5476,6 @@
           <a:lstStyle/>
           <a:p>
             <a:r>
-              <a:rPr/>
               <a:t>Mastercard – Comercial, Alto Valor e Outros</a:t>
             </a:r>
           </a:p>
@@ -3965,37 +5491,410 @@
             <p:ph idx="1"/>
           </p:nvPr>
         </p:nvSpPr>
-        <p:spPr/>
-        <p:txBody>
-          <a:bodyPr/>
+        <p:spPr>
+          <a:xfrm>
+            <a:off x="457200" y="1166018"/>
+            <a:ext cx="8229600" cy="4525963"/>
+          </a:xfrm>
+        </p:spPr>
+        <p:txBody>
+          <a:bodyPr>
+            <a:normAutofit fontScale="70000" lnSpcReduction="20000"/>
+          </a:bodyPr>
           <a:lstStyle/>
-          <a:p/>
-          <a:p>
-            <a:pPr/>
-            <a:r>
-              <a:rPr/>
-              <a:t>Crédito Comercial: Business (1,65%), Affluent (1,80%), CTA (1,80%), P‑Card (0,75%), Agro (1,65%). Segmentos variam, com valores entre 1,30% e 1,95%.</a:t>
-            </a:r>
-          </a:p>
-          <a:p>
-            <a:pPr/>
-            <a:r>
-              <a:rPr/>
-              <a:t>Transações de alto valor (consumidor e comercial): combinam taxa fixa (R$55 a R$440) + alíquota percentual (~0,17–0,30%). Mínimo de R$ 20 mil à vista ou R$ 10 mil por parcela para parcelamentos.</a:t>
-            </a:r>
-          </a:p>
-          <a:p>
-            <a:pPr/>
-            <a:r>
-              <a:rPr/>
-              <a:t>Pré‑pago (com e sem PIN): taxa base de 0,70% para todos os segmentos; alguns segmentos recebem 0,30% (despesas gerais, governo, transporte, loterias e micro comércios). Ajustes: compras não presenciais –0,40 p.p.; teto de R$0,30 por transação.</a:t>
-            </a:r>
-          </a:p>
-          <a:p>
-            <a:pPr/>
-            <a:r>
-              <a:rPr/>
-              <a:t>Débito (Maestro): taxa base de 0,50%; supermercados 0,45%; despesas gerais 0,25%; atacadistas 0,35%; outros 0,50%; ajustes para transações não presenciais variam de –0,25 p.p. a 0.00 p.p.; teto de R$0,30 por transação.</a:t>
+          <a:p>
+            <a:endParaRPr dirty="0"/>
+          </a:p>
+          <a:p>
+            <a:r>
+              <a:rPr dirty="0" err="1"/>
+              <a:t>Crédito</a:t>
+            </a:r>
+            <a:r>
+              <a:rPr dirty="0"/>
+              <a:t> </a:t>
+            </a:r>
+            <a:r>
+              <a:rPr dirty="0" err="1"/>
+              <a:t>Comercial</a:t>
+            </a:r>
+            <a:r>
+              <a:rPr dirty="0"/>
+              <a:t>: Business (1,65%), Affluent (1,80%), CTA (1,80%), P‑Card (0,75%), </a:t>
+            </a:r>
+            <a:r>
+              <a:rPr dirty="0" err="1"/>
+              <a:t>Agro</a:t>
+            </a:r>
+            <a:r>
+              <a:rPr dirty="0"/>
+              <a:t> (1,65%). </a:t>
+            </a:r>
+            <a:r>
+              <a:rPr dirty="0" err="1"/>
+              <a:t>Segmentos</a:t>
+            </a:r>
+            <a:r>
+              <a:rPr dirty="0"/>
+              <a:t> </a:t>
+            </a:r>
+            <a:r>
+              <a:rPr dirty="0" err="1"/>
+              <a:t>variam</a:t>
+            </a:r>
+            <a:r>
+              <a:rPr dirty="0"/>
+              <a:t>, com </a:t>
+            </a:r>
+            <a:r>
+              <a:rPr dirty="0" err="1"/>
+              <a:t>valores</a:t>
+            </a:r>
+            <a:r>
+              <a:rPr dirty="0"/>
+              <a:t> entre 1,30% e 1,95%.</a:t>
+            </a:r>
+          </a:p>
+          <a:p>
+            <a:r>
+              <a:rPr dirty="0" err="1"/>
+              <a:t>Transações</a:t>
+            </a:r>
+            <a:r>
+              <a:rPr dirty="0"/>
+              <a:t> de alto valor (</a:t>
+            </a:r>
+            <a:r>
+              <a:rPr dirty="0" err="1"/>
+              <a:t>consumidor</a:t>
+            </a:r>
+            <a:r>
+              <a:rPr dirty="0"/>
+              <a:t> e </a:t>
+            </a:r>
+            <a:r>
+              <a:rPr dirty="0" err="1"/>
+              <a:t>comercial</a:t>
+            </a:r>
+            <a:r>
+              <a:rPr dirty="0"/>
+              <a:t>): </a:t>
+            </a:r>
+            <a:r>
+              <a:rPr dirty="0" err="1"/>
+              <a:t>combinam</a:t>
+            </a:r>
+            <a:r>
+              <a:rPr dirty="0"/>
+              <a:t> taxa </a:t>
+            </a:r>
+            <a:r>
+              <a:rPr dirty="0" err="1"/>
+              <a:t>fixa</a:t>
+            </a:r>
+            <a:r>
+              <a:rPr dirty="0"/>
+              <a:t> (R$55 a R$440) + </a:t>
+            </a:r>
+            <a:r>
+              <a:rPr dirty="0" err="1"/>
+              <a:t>alíquota</a:t>
+            </a:r>
+            <a:r>
+              <a:rPr dirty="0"/>
+              <a:t> percentual (~0,17–0,30%). </a:t>
+            </a:r>
+            <a:r>
+              <a:rPr dirty="0" err="1"/>
+              <a:t>Mínimo</a:t>
+            </a:r>
+            <a:r>
+              <a:rPr dirty="0"/>
+              <a:t> de R$ 20 mil à vista </a:t>
+            </a:r>
+            <a:r>
+              <a:rPr dirty="0" err="1"/>
+              <a:t>ou</a:t>
+            </a:r>
+            <a:r>
+              <a:rPr dirty="0"/>
+              <a:t> R$ 10 mil por </a:t>
+            </a:r>
+            <a:r>
+              <a:rPr dirty="0" err="1"/>
+              <a:t>parcela</a:t>
+            </a:r>
+            <a:r>
+              <a:rPr dirty="0"/>
+              <a:t> para </a:t>
+            </a:r>
+            <a:r>
+              <a:rPr dirty="0" err="1"/>
+              <a:t>parcelamentos</a:t>
+            </a:r>
+            <a:r>
+              <a:rPr dirty="0"/>
+              <a:t>.</a:t>
+            </a:r>
+          </a:p>
+          <a:p>
+            <a:r>
+              <a:rPr dirty="0" err="1"/>
+              <a:t>Pré‑pago</a:t>
+            </a:r>
+            <a:r>
+              <a:rPr dirty="0"/>
+              <a:t> (com e </a:t>
+            </a:r>
+            <a:r>
+              <a:rPr dirty="0" err="1"/>
+              <a:t>sem</a:t>
+            </a:r>
+            <a:r>
+              <a:rPr dirty="0"/>
+              <a:t> PIN): taxa base de 0,70% para </a:t>
+            </a:r>
+            <a:r>
+              <a:rPr dirty="0" err="1"/>
+              <a:t>todos</a:t>
+            </a:r>
+            <a:r>
+              <a:rPr dirty="0"/>
+              <a:t> </a:t>
+            </a:r>
+            <a:r>
+              <a:rPr dirty="0" err="1"/>
+              <a:t>os</a:t>
+            </a:r>
+            <a:r>
+              <a:rPr dirty="0"/>
+              <a:t> </a:t>
+            </a:r>
+            <a:r>
+              <a:rPr dirty="0" err="1"/>
+              <a:t>segmentos</a:t>
+            </a:r>
+            <a:r>
+              <a:rPr dirty="0"/>
+              <a:t>; </a:t>
+            </a:r>
+            <a:r>
+              <a:rPr dirty="0" err="1"/>
+              <a:t>alguns</a:t>
+            </a:r>
+            <a:r>
+              <a:rPr dirty="0"/>
+              <a:t> </a:t>
+            </a:r>
+            <a:r>
+              <a:rPr dirty="0" err="1"/>
+              <a:t>segmentos</a:t>
+            </a:r>
+            <a:r>
+              <a:rPr dirty="0"/>
+              <a:t> </a:t>
+            </a:r>
+            <a:r>
+              <a:rPr dirty="0" err="1"/>
+              <a:t>recebem</a:t>
+            </a:r>
+            <a:r>
+              <a:rPr dirty="0"/>
+              <a:t> 0,30% (</a:t>
+            </a:r>
+            <a:r>
+              <a:rPr dirty="0" err="1"/>
+              <a:t>despesas</a:t>
+            </a:r>
+            <a:r>
+              <a:rPr dirty="0"/>
+              <a:t> </a:t>
+            </a:r>
+            <a:r>
+              <a:rPr dirty="0" err="1"/>
+              <a:t>gerais</a:t>
+            </a:r>
+            <a:r>
+              <a:rPr dirty="0"/>
+              <a:t>, </a:t>
+            </a:r>
+            <a:r>
+              <a:rPr dirty="0" err="1"/>
+              <a:t>governo</a:t>
+            </a:r>
+            <a:r>
+              <a:rPr dirty="0"/>
+              <a:t>, </a:t>
+            </a:r>
+            <a:r>
+              <a:rPr dirty="0" err="1"/>
+              <a:t>transporte</a:t>
+            </a:r>
+            <a:r>
+              <a:rPr dirty="0"/>
+              <a:t>, </a:t>
+            </a:r>
+            <a:r>
+              <a:rPr dirty="0" err="1"/>
+              <a:t>loterias</a:t>
+            </a:r>
+            <a:r>
+              <a:rPr dirty="0"/>
+              <a:t> e micro </a:t>
+            </a:r>
+            <a:r>
+              <a:rPr dirty="0" err="1"/>
+              <a:t>comércios</a:t>
+            </a:r>
+            <a:r>
+              <a:rPr dirty="0"/>
+              <a:t>). </a:t>
+            </a:r>
+            <a:r>
+              <a:rPr dirty="0" err="1"/>
+              <a:t>Ajustes</a:t>
+            </a:r>
+            <a:r>
+              <a:rPr dirty="0"/>
+              <a:t>: </a:t>
+            </a:r>
+            <a:r>
+              <a:rPr dirty="0" err="1"/>
+              <a:t>compras</a:t>
+            </a:r>
+            <a:r>
+              <a:rPr dirty="0"/>
+              <a:t> </a:t>
+            </a:r>
+            <a:r>
+              <a:rPr dirty="0" err="1"/>
+              <a:t>não</a:t>
+            </a:r>
+            <a:r>
+              <a:rPr dirty="0"/>
+              <a:t> </a:t>
+            </a:r>
+            <a:r>
+              <a:rPr dirty="0" err="1"/>
+              <a:t>presenciais</a:t>
+            </a:r>
+            <a:r>
+              <a:rPr dirty="0"/>
+              <a:t> –0,40 p.p.; </a:t>
+            </a:r>
+            <a:r>
+              <a:rPr dirty="0" err="1"/>
+              <a:t>teto</a:t>
+            </a:r>
+            <a:r>
+              <a:rPr dirty="0"/>
+              <a:t> de R$0,30 por </a:t>
+            </a:r>
+            <a:r>
+              <a:rPr dirty="0" err="1"/>
+              <a:t>transação</a:t>
+            </a:r>
+            <a:r>
+              <a:rPr dirty="0"/>
+              <a:t>.</a:t>
+            </a:r>
+          </a:p>
+          <a:p>
+            <a:r>
+              <a:rPr dirty="0" err="1"/>
+              <a:t>Débito</a:t>
+            </a:r>
+            <a:r>
+              <a:rPr dirty="0"/>
+              <a:t> (Maestro): taxa base de 0,50%; </a:t>
+            </a:r>
+            <a:r>
+              <a:rPr dirty="0" err="1"/>
+              <a:t>supermercados</a:t>
+            </a:r>
+            <a:r>
+              <a:rPr dirty="0"/>
+              <a:t> 0,45%; </a:t>
+            </a:r>
+            <a:r>
+              <a:rPr dirty="0" err="1"/>
+              <a:t>despesas</a:t>
+            </a:r>
+            <a:r>
+              <a:rPr dirty="0"/>
+              <a:t> </a:t>
+            </a:r>
+            <a:r>
+              <a:rPr dirty="0" err="1"/>
+              <a:t>gerais</a:t>
+            </a:r>
+            <a:r>
+              <a:rPr dirty="0"/>
+              <a:t> 0,25%; </a:t>
+            </a:r>
+            <a:r>
+              <a:rPr dirty="0" err="1"/>
+              <a:t>atacadistas</a:t>
+            </a:r>
+            <a:r>
+              <a:rPr dirty="0"/>
+              <a:t> 0,35%; outros 0,50%; </a:t>
+            </a:r>
+            <a:r>
+              <a:rPr dirty="0" err="1"/>
+              <a:t>ajustes</a:t>
+            </a:r>
+            <a:r>
+              <a:rPr dirty="0"/>
+              <a:t> para </a:t>
+            </a:r>
+            <a:r>
+              <a:rPr dirty="0" err="1"/>
+              <a:t>transações</a:t>
+            </a:r>
+            <a:r>
+              <a:rPr dirty="0"/>
+              <a:t> </a:t>
+            </a:r>
+            <a:r>
+              <a:rPr dirty="0" err="1"/>
+              <a:t>não</a:t>
+            </a:r>
+            <a:r>
+              <a:rPr dirty="0"/>
+              <a:t> </a:t>
+            </a:r>
+            <a:r>
+              <a:rPr dirty="0" err="1"/>
+              <a:t>presenciais</a:t>
+            </a:r>
+            <a:r>
+              <a:rPr dirty="0"/>
+              <a:t> </a:t>
+            </a:r>
+            <a:r>
+              <a:rPr dirty="0" err="1"/>
+              <a:t>variam</a:t>
+            </a:r>
+            <a:r>
+              <a:rPr dirty="0"/>
+              <a:t> de –0,25 p.p. a 0.00 p.p.; </a:t>
+            </a:r>
+            <a:r>
+              <a:rPr dirty="0" err="1"/>
+              <a:t>teto</a:t>
+            </a:r>
+            <a:r>
+              <a:rPr dirty="0"/>
+              <a:t> de R$0,30 por </a:t>
+            </a:r>
+            <a:r>
+              <a:rPr dirty="0" err="1"/>
+              <a:t>transação</a:t>
+            </a:r>
+            <a:r>
+              <a:rPr dirty="0"/>
+              <a:t>.</a:t>
             </a:r>
           </a:p>
         </p:txBody>
@@ -4009,7 +5908,7 @@
 </file>
 
 <file path=ppt/slides/slide8.xml><?xml version="1.0" encoding="utf-8"?>
-<p:sld xmlns:a="http://schemas.openxmlformats.org/drawingml/2006/main" xmlns:p="http://schemas.openxmlformats.org/presentationml/2006/main" xmlns:r="http://schemas.openxmlformats.org/officeDocument/2006/relationships">
+<p:sld xmlns:a="http://schemas.openxmlformats.org/drawingml/2006/main" xmlns:r="http://schemas.openxmlformats.org/officeDocument/2006/relationships" xmlns:p="http://schemas.openxmlformats.org/presentationml/2006/main">
   <p:cSld>
     <p:spTree>
       <p:nvGrpSpPr>
@@ -4017,7 +5916,14 @@
         <p:cNvGrpSpPr/>
         <p:nvPr/>
       </p:nvGrpSpPr>
-      <p:grpSpPr/>
+      <p:grpSpPr>
+        <a:xfrm>
+          <a:off x="0" y="0"/>
+          <a:ext cx="0" cy="0"/>
+          <a:chOff x="0" y="0"/>
+          <a:chExt cx="0" cy="0"/>
+        </a:xfrm>
+      </p:grpSpPr>
       <p:sp>
         <p:nvSpPr>
           <p:cNvPr id="2" name="Title 1"/>
@@ -4034,7 +5940,6 @@
           <a:lstStyle/>
           <a:p>
             <a:r>
-              <a:rPr/>
               <a:t>Estatísticas de Pagamentos – Banco Central (BCB) 2023</a:t>
             </a:r>
           </a:p>
@@ -4050,19 +5955,151 @@
             <p:ph idx="1"/>
           </p:nvPr>
         </p:nvSpPr>
-        <p:spPr/>
-        <p:txBody>
-          <a:bodyPr/>
+        <p:spPr>
+          <a:xfrm>
+            <a:off x="457200" y="1349189"/>
+            <a:ext cx="8229600" cy="4525963"/>
+          </a:xfrm>
+        </p:spPr>
+        <p:txBody>
+          <a:bodyPr>
+            <a:normAutofit fontScale="70000" lnSpcReduction="20000"/>
+          </a:bodyPr>
           <a:lstStyle/>
-          <a:p/>
-          <a:p>
-            <a:pPr/>
-            <a:r>
-              <a:rPr/>
-              <a:t>Foram realizadas 108,7 bilhões de transações não monetárias em 2023, movimentando R$ 99,7 trilhões (≈9,1× o PIB). Houve crescimento de 31% na quantidade de transações e 9% no volume em relação a 2022</a:t>
-            </a:r>
-            <a:r>
-              <a:rPr u="sng">
+          <a:p>
+            <a:endParaRPr dirty="0"/>
+          </a:p>
+          <a:p>
+            <a:r>
+              <a:rPr dirty="0" err="1"/>
+              <a:t>Foram</a:t>
+            </a:r>
+            <a:r>
+              <a:rPr dirty="0"/>
+              <a:t> </a:t>
+            </a:r>
+            <a:r>
+              <a:rPr dirty="0" err="1"/>
+              <a:t>realizadas</a:t>
+            </a:r>
+            <a:r>
+              <a:rPr dirty="0"/>
+              <a:t> 108,7 </a:t>
+            </a:r>
+            <a:r>
+              <a:rPr dirty="0" err="1"/>
+              <a:t>bilhões</a:t>
+            </a:r>
+            <a:r>
+              <a:rPr dirty="0"/>
+              <a:t> de </a:t>
+            </a:r>
+            <a:r>
+              <a:rPr dirty="0" err="1"/>
+              <a:t>transações</a:t>
+            </a:r>
+            <a:r>
+              <a:rPr dirty="0"/>
+              <a:t> </a:t>
+            </a:r>
+            <a:r>
+              <a:rPr dirty="0" err="1"/>
+              <a:t>não</a:t>
+            </a:r>
+            <a:r>
+              <a:rPr dirty="0"/>
+              <a:t> </a:t>
+            </a:r>
+            <a:r>
+              <a:rPr dirty="0" err="1"/>
+              <a:t>monetárias</a:t>
+            </a:r>
+            <a:r>
+              <a:rPr dirty="0"/>
+              <a:t> </a:t>
+            </a:r>
+            <a:r>
+              <a:rPr dirty="0" err="1"/>
+              <a:t>em</a:t>
+            </a:r>
+            <a:r>
+              <a:rPr dirty="0"/>
+              <a:t> 2023, </a:t>
+            </a:r>
+            <a:r>
+              <a:rPr dirty="0" err="1"/>
+              <a:t>movimentando</a:t>
+            </a:r>
+            <a:r>
+              <a:rPr dirty="0"/>
+              <a:t> R$ 99,7 </a:t>
+            </a:r>
+            <a:r>
+              <a:rPr dirty="0" err="1"/>
+              <a:t>trilhões</a:t>
+            </a:r>
+            <a:r>
+              <a:rPr dirty="0"/>
+              <a:t> (≈9,1× o PIB). </a:t>
+            </a:r>
+            <a:r>
+              <a:rPr dirty="0" err="1"/>
+              <a:t>Houve</a:t>
+            </a:r>
+            <a:r>
+              <a:rPr dirty="0"/>
+              <a:t> </a:t>
+            </a:r>
+            <a:r>
+              <a:rPr dirty="0" err="1"/>
+              <a:t>crescimento</a:t>
+            </a:r>
+            <a:r>
+              <a:rPr dirty="0"/>
+              <a:t> de 31% </a:t>
+            </a:r>
+            <a:r>
+              <a:rPr dirty="0" err="1"/>
+              <a:t>na</a:t>
+            </a:r>
+            <a:r>
+              <a:rPr dirty="0"/>
+              <a:t> </a:t>
+            </a:r>
+            <a:r>
+              <a:rPr dirty="0" err="1"/>
+              <a:t>quantidade</a:t>
+            </a:r>
+            <a:r>
+              <a:rPr dirty="0"/>
+              <a:t> de </a:t>
+            </a:r>
+            <a:r>
+              <a:rPr dirty="0" err="1"/>
+              <a:t>transações</a:t>
+            </a:r>
+            <a:r>
+              <a:rPr dirty="0"/>
+              <a:t> e 9% no volume </a:t>
+            </a:r>
+            <a:r>
+              <a:rPr dirty="0" err="1"/>
+              <a:t>em</a:t>
+            </a:r>
+            <a:r>
+              <a:rPr dirty="0"/>
+              <a:t> </a:t>
+            </a:r>
+            <a:r>
+              <a:rPr dirty="0" err="1"/>
+              <a:t>relação</a:t>
+            </a:r>
+            <a:r>
+              <a:rPr dirty="0"/>
+              <a:t> a 2022</a:t>
+            </a:r>
+            <a:r>
+              <a:rPr u="sng" dirty="0">
                 <a:solidFill>
                   <a:schemeClr val="accent6"/>
                 </a:solidFill>
@@ -4071,18 +6108,49 @@
               <a:t>(www.demarest.com.br)</a:t>
             </a:r>
             <a:r>
-              <a:rPr/>
+              <a:rPr dirty="0"/>
               <a:t>.</a:t>
             </a:r>
           </a:p>
           <a:p>
-            <a:pPr/>
-            <a:r>
-              <a:rPr/>
-              <a:t>O Pix representou 39% das transações e os cartões 41%</a:t>
-            </a:r>
-            <a:r>
-              <a:rPr u="sng">
+            <a:r>
+              <a:rPr dirty="0"/>
+              <a:t>O Pix </a:t>
+            </a:r>
+            <a:r>
+              <a:rPr dirty="0" err="1"/>
+              <a:t>representou</a:t>
+            </a:r>
+            <a:r>
+              <a:rPr dirty="0"/>
+              <a:t> 39% das </a:t>
+            </a:r>
+            <a:r>
+              <a:rPr dirty="0" err="1"/>
+              <a:t>transações</a:t>
+            </a:r>
+            <a:r>
+              <a:rPr dirty="0"/>
+              <a:t> e </a:t>
+            </a:r>
+            <a:r>
+              <a:rPr dirty="0" err="1"/>
+              <a:t>os</a:t>
+            </a:r>
+            <a:r>
+              <a:rPr dirty="0"/>
+              <a:t> </a:t>
+            </a:r>
+            <a:r>
+              <a:rPr dirty="0" err="1"/>
+              <a:t>cartões</a:t>
+            </a:r>
+            <a:r>
+              <a:rPr dirty="0"/>
+              <a:t> 41%</a:t>
+            </a:r>
+            <a:r>
+              <a:rPr u="sng" dirty="0">
                 <a:solidFill>
                   <a:schemeClr val="accent6"/>
                 </a:solidFill>
@@ -4091,11 +6159,55 @@
               <a:t>(www.demarest.com.br)</a:t>
             </a:r>
             <a:r>
-              <a:rPr/>
-              <a:t>. O pré‑pago cresceu 36% em 2023, respondendo por 23% das transações com cartões</a:t>
-            </a:r>
-            <a:r>
-              <a:rPr u="sng">
+              <a:rPr dirty="0"/>
+              <a:t>. O </a:t>
+            </a:r>
+            <a:r>
+              <a:rPr dirty="0" err="1"/>
+              <a:t>pré‑pago</a:t>
+            </a:r>
+            <a:r>
+              <a:rPr dirty="0"/>
+              <a:t> </a:t>
+            </a:r>
+            <a:r>
+              <a:rPr dirty="0" err="1"/>
+              <a:t>cresceu</a:t>
+            </a:r>
+            <a:r>
+              <a:rPr dirty="0"/>
+              <a:t> 36% </a:t>
+            </a:r>
+            <a:r>
+              <a:rPr dirty="0" err="1"/>
+              <a:t>em</a:t>
+            </a:r>
+            <a:r>
+              <a:rPr dirty="0"/>
+              <a:t> 2023, </a:t>
+            </a:r>
+            <a:r>
+              <a:rPr dirty="0" err="1"/>
+              <a:t>respondendo</a:t>
+            </a:r>
+            <a:r>
+              <a:rPr dirty="0"/>
+              <a:t> por 23% das </a:t>
+            </a:r>
+            <a:r>
+              <a:rPr dirty="0" err="1"/>
+              <a:t>transações</a:t>
+            </a:r>
+            <a:r>
+              <a:rPr dirty="0"/>
+              <a:t> com </a:t>
+            </a:r>
+            <a:r>
+              <a:rPr dirty="0" err="1"/>
+              <a:t>cartões</a:t>
+            </a:r>
+            <a:r>
+              <a:rPr u="sng" dirty="0">
                 <a:solidFill>
                   <a:schemeClr val="accent6"/>
                 </a:solidFill>
@@ -4104,11 +6216,7 @@
               <a:t>(www.demarest.com.br)</a:t>
             </a:r>
             <a:r>
-              <a:rPr/>
-              <a:t/>
-            </a:r>
-            <a:r>
-              <a:rPr u="sng">
+              <a:rPr u="sng" dirty="0">
                 <a:solidFill>
                   <a:schemeClr val="accent6"/>
                 </a:solidFill>
@@ -4117,18 +6225,61 @@
               <a:t>(www.demarest.com.br)</a:t>
             </a:r>
             <a:r>
-              <a:rPr/>
+              <a:rPr dirty="0"/>
               <a:t>.</a:t>
             </a:r>
           </a:p>
           <a:p>
-            <a:pPr/>
-            <a:r>
-              <a:rPr/>
-              <a:t>Valores médios por transação: crédito R$128, débito R$61 e pré‑pago R$26</a:t>
-            </a:r>
-            <a:r>
-              <a:rPr u="sng">
+            <a:r>
+              <a:rPr dirty="0" err="1"/>
+              <a:t>Valores</a:t>
+            </a:r>
+            <a:r>
+              <a:rPr dirty="0"/>
+              <a:t> </a:t>
+            </a:r>
+            <a:r>
+              <a:rPr dirty="0" err="1"/>
+              <a:t>médios</a:t>
+            </a:r>
+            <a:r>
+              <a:rPr dirty="0"/>
+              <a:t> por </a:t>
+            </a:r>
+            <a:r>
+              <a:rPr dirty="0" err="1"/>
+              <a:t>transação</a:t>
+            </a:r>
+            <a:r>
+              <a:rPr dirty="0"/>
+              <a:t>: </a:t>
+            </a:r>
+            <a:r>
+              <a:rPr dirty="0" err="1"/>
+              <a:t>crédito</a:t>
+            </a:r>
+            <a:r>
+              <a:rPr dirty="0"/>
+              <a:t> R$128, </a:t>
+            </a:r>
+            <a:r>
+              <a:rPr dirty="0" err="1"/>
+              <a:t>débito</a:t>
+            </a:r>
+            <a:r>
+              <a:rPr dirty="0"/>
+              <a:t> R$61 e </a:t>
+            </a:r>
+            <a:r>
+              <a:rPr dirty="0" err="1"/>
+              <a:t>pré‑pago</a:t>
+            </a:r>
+            <a:r>
+              <a:rPr dirty="0"/>
+              <a:t> R$26</a:t>
+            </a:r>
+            <a:r>
+              <a:rPr u="sng" dirty="0">
                 <a:solidFill>
                   <a:schemeClr val="accent6"/>
                 </a:solidFill>
@@ -4137,18 +6288,137 @@
               <a:t>(www.demarest.com.br)</a:t>
             </a:r>
             <a:r>
-              <a:rPr/>
+              <a:rPr dirty="0"/>
               <a:t>.</a:t>
             </a:r>
           </a:p>
           <a:p>
-            <a:pPr/>
-            <a:r>
-              <a:rPr/>
-              <a:t>As tarifas de intercâmbio de crédito mantiveram‑se estáveis; débitos e pré‑pagos caíram em razão da limitação imposta pelo BC (0,5% para débito e 0,7% para pré‑pago)</a:t>
-            </a:r>
-            <a:r>
-              <a:rPr u="sng">
+            <a:r>
+              <a:rPr dirty="0"/>
+              <a:t>As </a:t>
+            </a:r>
+            <a:r>
+              <a:rPr dirty="0" err="1"/>
+              <a:t>tarifas</a:t>
+            </a:r>
+            <a:r>
+              <a:rPr dirty="0"/>
+              <a:t> de </a:t>
+            </a:r>
+            <a:r>
+              <a:rPr dirty="0" err="1"/>
+              <a:t>intercâmbio</a:t>
+            </a:r>
+            <a:r>
+              <a:rPr dirty="0"/>
+              <a:t> de </a:t>
+            </a:r>
+            <a:r>
+              <a:rPr dirty="0" err="1"/>
+              <a:t>crédito</a:t>
+            </a:r>
+            <a:r>
+              <a:rPr dirty="0"/>
+              <a:t> </a:t>
+            </a:r>
+            <a:r>
+              <a:rPr dirty="0" err="1"/>
+              <a:t>mantiveram</a:t>
+            </a:r>
+            <a:r>
+              <a:rPr dirty="0"/>
+              <a:t>‑se </a:t>
+            </a:r>
+            <a:r>
+              <a:rPr dirty="0" err="1"/>
+              <a:t>estáveis</a:t>
+            </a:r>
+            <a:r>
+              <a:rPr dirty="0"/>
+              <a:t>; </a:t>
+            </a:r>
+            <a:r>
+              <a:rPr dirty="0" err="1"/>
+              <a:t>débitos</a:t>
+            </a:r>
+            <a:r>
+              <a:rPr dirty="0"/>
+              <a:t> e </a:t>
+            </a:r>
+            <a:r>
+              <a:rPr dirty="0" err="1"/>
+              <a:t>pré‑pagos</a:t>
+            </a:r>
+            <a:r>
+              <a:rPr dirty="0"/>
+              <a:t> </a:t>
+            </a:r>
+            <a:r>
+              <a:rPr dirty="0" err="1"/>
+              <a:t>caíram</a:t>
+            </a:r>
+            <a:r>
+              <a:rPr dirty="0"/>
+              <a:t> </a:t>
+            </a:r>
+            <a:r>
+              <a:rPr dirty="0" err="1"/>
+              <a:t>em</a:t>
+            </a:r>
+            <a:r>
+              <a:rPr dirty="0"/>
+              <a:t> </a:t>
+            </a:r>
+            <a:r>
+              <a:rPr dirty="0" err="1"/>
+              <a:t>razão</a:t>
+            </a:r>
+            <a:r>
+              <a:rPr dirty="0"/>
+              <a:t> da </a:t>
+            </a:r>
+            <a:r>
+              <a:rPr dirty="0" err="1"/>
+              <a:t>limitação</a:t>
+            </a:r>
+            <a:r>
+              <a:rPr dirty="0"/>
+              <a:t> </a:t>
+            </a:r>
+            <a:r>
+              <a:rPr dirty="0" err="1"/>
+              <a:t>imposta</a:t>
+            </a:r>
+            <a:r>
+              <a:rPr dirty="0"/>
+              <a:t> </a:t>
+            </a:r>
+            <a:r>
+              <a:rPr dirty="0" err="1"/>
+              <a:t>pelo</a:t>
+            </a:r>
+            <a:r>
+              <a:rPr dirty="0"/>
+              <a:t> BC (0,5% para </a:t>
+            </a:r>
+            <a:r>
+              <a:rPr dirty="0" err="1"/>
+              <a:t>débito</a:t>
+            </a:r>
+            <a:r>
+              <a:rPr dirty="0"/>
+              <a:t> e 0,7% para </a:t>
+            </a:r>
+            <a:r>
+              <a:rPr dirty="0" err="1"/>
+              <a:t>pré‑pago</a:t>
+            </a:r>
+            <a:r>
+              <a:rPr dirty="0"/>
+              <a:t>)</a:t>
+            </a:r>
+            <a:r>
+              <a:rPr u="sng" dirty="0">
                 <a:solidFill>
                   <a:schemeClr val="accent6"/>
                 </a:solidFill>
@@ -4157,7 +6427,7 @@
               <a:t>(regulacaoemnumeros-direitorio.fgv.br)</a:t>
             </a:r>
             <a:r>
-              <a:rPr/>
+              <a:rPr dirty="0"/>
               <a:t>.</a:t>
             </a:r>
           </a:p>
@@ -4172,7 +6442,7 @@
 </file>
 
 <file path=ppt/slides/slide9.xml><?xml version="1.0" encoding="utf-8"?>
-<p:sld xmlns:a="http://schemas.openxmlformats.org/drawingml/2006/main" xmlns:p="http://schemas.openxmlformats.org/presentationml/2006/main" xmlns:r="http://schemas.openxmlformats.org/officeDocument/2006/relationships">
+<p:sld xmlns:a="http://schemas.openxmlformats.org/drawingml/2006/main" xmlns:r="http://schemas.openxmlformats.org/officeDocument/2006/relationships" xmlns:p="http://schemas.openxmlformats.org/presentationml/2006/main">
   <p:cSld>
     <p:spTree>
       <p:nvGrpSpPr>
@@ -4180,7 +6450,14 @@
         <p:cNvGrpSpPr/>
         <p:nvPr/>
       </p:nvGrpSpPr>
-      <p:grpSpPr/>
+      <p:grpSpPr>
+        <a:xfrm>
+          <a:off x="0" y="0"/>
+          <a:ext cx="0" cy="0"/>
+          <a:chOff x="0" y="0"/>
+          <a:chExt cx="0" cy="0"/>
+        </a:xfrm>
+      </p:grpSpPr>
       <p:sp>
         <p:nvSpPr>
           <p:cNvPr id="2" name="Title 1"/>
@@ -4197,7 +6474,6 @@
           <a:lstStyle/>
           <a:p>
             <a:r>
-              <a:rPr/>
               <a:t>Comparação de Taxas Base de Crédito (Consumidor)</a:t>
             </a:r>
           </a:p>
@@ -4217,7 +6493,7 @@
         </p:xfrm>
         <a:graphic>
           <a:graphicData uri="http://schemas.openxmlformats.org/drawingml/2006/chart">
-            <c:chart xmlns:c="http://schemas.openxmlformats.org/drawingml/2006/chart" r:id="rId2"/>
+            <c:chart xmlns:c="http://schemas.openxmlformats.org/drawingml/2006/chart" xmlns:r="http://schemas.openxmlformats.org/officeDocument/2006/relationships" r:id="rId2"/>
           </a:graphicData>
         </a:graphic>
       </p:graphicFrame>

</xml_diff>